<commit_message>
Show the increase step in linked percentage examples
</commit_message>
<xml_diff>
--- a/public/lessons/year-6-maths/summer/week-29/choose-efficient-representations/teaching-powerpoint-v1.pptx
+++ b/public/lessons/year-6-maths/summer/week-29/choose-efficient-representations/teaching-powerpoint-v1.pptx
@@ -1556,7 +1556,7 @@
           <p:cNvPr id="7" name="object-1">
             <a:extLst>
               <a:ext uri="{FF2B5EF4-FFF2-40B4-BE49-F238E27FC236}">
-                <a16:creationId xmlns:a16="http://schemas.microsoft.com/office/drawing/2014/main" id="{0606C7AB-6D50-49E8-B09C-BF9BA1D1B291}"/>
+                <a16:creationId xmlns:a16="http://schemas.microsoft.com/office/drawing/2014/main" id="{36434F53-4553-4F50-A972-46B61FFDF4D5}"/>
               </a:ext>
             </a:extLst>
           </p:cNvPr>
@@ -1613,7 +1613,7 @@
           <p:cNvPr id="2" name="object-2">
             <a:extLst>
               <a:ext uri="{FF2B5EF4-FFF2-40B4-BE49-F238E27FC236}">
-                <a16:creationId xmlns:a16="http://schemas.microsoft.com/office/drawing/2014/main" id="{B6AC93D6-EC7E-4220-A3AE-610DA56544A5}"/>
+                <a16:creationId xmlns:a16="http://schemas.microsoft.com/office/drawing/2014/main" id="{1A143B4D-2A66-4D11-B578-D85641EE9541}"/>
               </a:ext>
             </a:extLst>
           </p:cNvPr>
@@ -1670,7 +1670,7 @@
           <p:cNvPr id="3" name="object-3">
             <a:extLst>
               <a:ext uri="{FF2B5EF4-FFF2-40B4-BE49-F238E27FC236}">
-                <a16:creationId xmlns:a16="http://schemas.microsoft.com/office/drawing/2014/main" id="{DEFC9C1A-C9A6-455F-B174-6FE993497EAD}"/>
+                <a16:creationId xmlns:a16="http://schemas.microsoft.com/office/drawing/2014/main" id="{29C56922-6F8D-40BA-9636-9B3509968272}"/>
               </a:ext>
             </a:extLst>
           </p:cNvPr>
@@ -1700,7 +1700,7 @@
           <p:cNvPr id="4" name="object-4">
             <a:extLst>
               <a:ext uri="{FF2B5EF4-FFF2-40B4-BE49-F238E27FC236}">
-                <a16:creationId xmlns:a16="http://schemas.microsoft.com/office/drawing/2014/main" id="{C2311A81-DB95-4DF9-A624-46F371D1FBF4}"/>
+                <a16:creationId xmlns:a16="http://schemas.microsoft.com/office/drawing/2014/main" id="{992EB2B3-72B5-400B-86E0-5C36F6B91196}"/>
               </a:ext>
             </a:extLst>
           </p:cNvPr>
@@ -1757,7 +1757,7 @@
           <p:cNvPr id="5" name="object-5">
             <a:extLst>
               <a:ext uri="{FF2B5EF4-FFF2-40B4-BE49-F238E27FC236}">
-                <a16:creationId xmlns:a16="http://schemas.microsoft.com/office/drawing/2014/main" id="{54B64D8A-4849-4013-99F0-4FEFD4A19414}"/>
+                <a16:creationId xmlns:a16="http://schemas.microsoft.com/office/drawing/2014/main" id="{6BF48273-B963-40DA-BC37-BC358925CFE6}"/>
               </a:ext>
             </a:extLst>
           </p:cNvPr>
@@ -1814,7 +1814,7 @@
           <p:cNvPr id="6" name="object-6">
             <a:extLst>
               <a:ext uri="{FF2B5EF4-FFF2-40B4-BE49-F238E27FC236}">
-                <a16:creationId xmlns:a16="http://schemas.microsoft.com/office/drawing/2014/main" id="{1060F860-2E7F-4B29-A10C-74762C4294D2}"/>
+                <a16:creationId xmlns:a16="http://schemas.microsoft.com/office/drawing/2014/main" id="{A130B299-490F-428A-B4BC-B65ABA960582}"/>
               </a:ext>
             </a:extLst>
           </p:cNvPr>
@@ -1869,7 +1869,7 @@
     </p:spTree>
     <p:extLst>
       <p:ext uri="{BB962C8B-B14F-4D97-AF65-F5344CB8AC3E}">
-        <p14:creationId xmlns:p14="http://schemas.microsoft.com/office/powerpoint/2010/main" val="614951011"/>
+        <p14:creationId xmlns:p14="http://schemas.microsoft.com/office/powerpoint/2010/main" val="1404967137"/>
       </p:ext>
     </p:extLst>
   </p:cSld>
@@ -1909,7 +1909,7 @@
           <p:cNvPr id="27" name="object-1">
             <a:extLst>
               <a:ext uri="{FF2B5EF4-FFF2-40B4-BE49-F238E27FC236}">
-                <a16:creationId xmlns:a16="http://schemas.microsoft.com/office/drawing/2014/main" id="{21DDD59E-5EBF-4D2B-9674-03CDC62C2EFD}"/>
+                <a16:creationId xmlns:a16="http://schemas.microsoft.com/office/drawing/2014/main" id="{AA697AC1-7E48-4727-8ABF-9B821B2E5975}"/>
               </a:ext>
             </a:extLst>
           </p:cNvPr>
@@ -1966,7 +1966,7 @@
           <p:cNvPr id="2" name="object-2">
             <a:extLst>
               <a:ext uri="{FF2B5EF4-FFF2-40B4-BE49-F238E27FC236}">
-                <a16:creationId xmlns:a16="http://schemas.microsoft.com/office/drawing/2014/main" id="{F9876A32-50CF-477B-8ACA-49F35E35965E}"/>
+                <a16:creationId xmlns:a16="http://schemas.microsoft.com/office/drawing/2014/main" id="{51D03783-5A7E-42E2-BAA2-CCC7280331F5}"/>
               </a:ext>
             </a:extLst>
           </p:cNvPr>
@@ -2023,7 +2023,7 @@
           <p:cNvPr id="3" name="object-3">
             <a:extLst>
               <a:ext uri="{FF2B5EF4-FFF2-40B4-BE49-F238E27FC236}">
-                <a16:creationId xmlns:a16="http://schemas.microsoft.com/office/drawing/2014/main" id="{C63539BA-D6A8-4A0F-9F07-2124BFE8610A}"/>
+                <a16:creationId xmlns:a16="http://schemas.microsoft.com/office/drawing/2014/main" id="{AE1E3405-1309-490E-A653-1583DD0FB28C}"/>
               </a:ext>
             </a:extLst>
           </p:cNvPr>
@@ -2080,7 +2080,7 @@
           <p:cNvPr id="4" name="object-4">
             <a:extLst>
               <a:ext uri="{FF2B5EF4-FFF2-40B4-BE49-F238E27FC236}">
-                <a16:creationId xmlns:a16="http://schemas.microsoft.com/office/drawing/2014/main" id="{0987553C-7C10-4441-A59C-52F972BD7079}"/>
+                <a16:creationId xmlns:a16="http://schemas.microsoft.com/office/drawing/2014/main" id="{5BD77AD5-6102-4E4E-9584-545132D2FA62}"/>
               </a:ext>
             </a:extLst>
           </p:cNvPr>
@@ -2110,7 +2110,7 @@
           <p:cNvPr id="5" name="object-5">
             <a:extLst>
               <a:ext uri="{FF2B5EF4-FFF2-40B4-BE49-F238E27FC236}">
-                <a16:creationId xmlns:a16="http://schemas.microsoft.com/office/drawing/2014/main" id="{AA6ED594-45D2-498B-87B9-415573572335}"/>
+                <a16:creationId xmlns:a16="http://schemas.microsoft.com/office/drawing/2014/main" id="{F8D4593E-1C09-47E3-9BBD-F20011239BF4}"/>
               </a:ext>
             </a:extLst>
           </p:cNvPr>
@@ -2167,7 +2167,7 @@
           <p:cNvPr id="6" name="object-6">
             <a:extLst>
               <a:ext uri="{FF2B5EF4-FFF2-40B4-BE49-F238E27FC236}">
-                <a16:creationId xmlns:a16="http://schemas.microsoft.com/office/drawing/2014/main" id="{683B3D78-C394-492B-A520-A5EB5FE87137}"/>
+                <a16:creationId xmlns:a16="http://schemas.microsoft.com/office/drawing/2014/main" id="{0FE4A36F-9440-4428-AEAD-954EC8DA7C26}"/>
               </a:ext>
             </a:extLst>
           </p:cNvPr>
@@ -2224,7 +2224,7 @@
           <p:cNvPr id="7" name="object-7">
             <a:extLst>
               <a:ext uri="{FF2B5EF4-FFF2-40B4-BE49-F238E27FC236}">
-                <a16:creationId xmlns:a16="http://schemas.microsoft.com/office/drawing/2014/main" id="{20FFD12B-7106-470F-BD8B-27C63D9F511F}"/>
+                <a16:creationId xmlns:a16="http://schemas.microsoft.com/office/drawing/2014/main" id="{4546D06A-09E2-4F30-BBF3-76E0F2C494FD}"/>
               </a:ext>
             </a:extLst>
           </p:cNvPr>
@@ -2281,7 +2281,7 @@
           <p:cNvPr id="8" name="object-8">
             <a:extLst>
               <a:ext uri="{FF2B5EF4-FFF2-40B4-BE49-F238E27FC236}">
-                <a16:creationId xmlns:a16="http://schemas.microsoft.com/office/drawing/2014/main" id="{C7027190-E7E7-452D-B607-12D9C2167BE6}"/>
+                <a16:creationId xmlns:a16="http://schemas.microsoft.com/office/drawing/2014/main" id="{4A4C445D-32EE-4C15-A287-B585C23D1941}"/>
               </a:ext>
             </a:extLst>
           </p:cNvPr>
@@ -2338,7 +2338,7 @@
           <p:cNvPr id="9" name="object-9">
             <a:extLst>
               <a:ext uri="{FF2B5EF4-FFF2-40B4-BE49-F238E27FC236}">
-                <a16:creationId xmlns:a16="http://schemas.microsoft.com/office/drawing/2014/main" id="{FADD5C01-7C5E-4F73-9CDE-9D7D0C5D3122}"/>
+                <a16:creationId xmlns:a16="http://schemas.microsoft.com/office/drawing/2014/main" id="{E4D98B77-1AB6-4CD1-BCD9-4222D735B641}"/>
               </a:ext>
             </a:extLst>
           </p:cNvPr>
@@ -2395,7 +2395,7 @@
           <p:cNvPr id="10" name="object-10">
             <a:extLst>
               <a:ext uri="{FF2B5EF4-FFF2-40B4-BE49-F238E27FC236}">
-                <a16:creationId xmlns:a16="http://schemas.microsoft.com/office/drawing/2014/main" id="{83319939-0D12-4FF7-84B3-C508396286BE}"/>
+                <a16:creationId xmlns:a16="http://schemas.microsoft.com/office/drawing/2014/main" id="{7B16E363-E417-4353-A033-EA45F0C56827}"/>
               </a:ext>
             </a:extLst>
           </p:cNvPr>
@@ -2452,7 +2452,7 @@
           <p:cNvPr id="11" name="object-11">
             <a:extLst>
               <a:ext uri="{FF2B5EF4-FFF2-40B4-BE49-F238E27FC236}">
-                <a16:creationId xmlns:a16="http://schemas.microsoft.com/office/drawing/2014/main" id="{A2F08A9A-5BD9-47A5-8AA5-118BD5433AFD}"/>
+                <a16:creationId xmlns:a16="http://schemas.microsoft.com/office/drawing/2014/main" id="{F5FF031D-D834-44CB-8D72-1F464DB0DF26}"/>
               </a:ext>
             </a:extLst>
           </p:cNvPr>
@@ -2509,7 +2509,7 @@
           <p:cNvPr id="12" name="object-12">
             <a:extLst>
               <a:ext uri="{FF2B5EF4-FFF2-40B4-BE49-F238E27FC236}">
-                <a16:creationId xmlns:a16="http://schemas.microsoft.com/office/drawing/2014/main" id="{216A390B-EC5D-4500-8D1C-4CC92435A5EB}"/>
+                <a16:creationId xmlns:a16="http://schemas.microsoft.com/office/drawing/2014/main" id="{C099C9E7-6A45-4C01-A30B-D481A5622A71}"/>
               </a:ext>
             </a:extLst>
           </p:cNvPr>
@@ -2566,7 +2566,7 @@
           <p:cNvPr id="13" name="object-13">
             <a:extLst>
               <a:ext uri="{FF2B5EF4-FFF2-40B4-BE49-F238E27FC236}">
-                <a16:creationId xmlns:a16="http://schemas.microsoft.com/office/drawing/2014/main" id="{A28B74CC-8499-4C13-976F-CEFD761767F4}"/>
+                <a16:creationId xmlns:a16="http://schemas.microsoft.com/office/drawing/2014/main" id="{C656BAF2-4F0C-4C06-9CE6-904D32F28A1B}"/>
               </a:ext>
             </a:extLst>
           </p:cNvPr>
@@ -2623,7 +2623,7 @@
           <p:cNvPr id="14" name="object-14">
             <a:extLst>
               <a:ext uri="{FF2B5EF4-FFF2-40B4-BE49-F238E27FC236}">
-                <a16:creationId xmlns:a16="http://schemas.microsoft.com/office/drawing/2014/main" id="{A1C9B858-F9C7-41F3-BE8B-FFD525D0CC5B}"/>
+                <a16:creationId xmlns:a16="http://schemas.microsoft.com/office/drawing/2014/main" id="{0659C6EA-3441-4C4C-B6DE-CBC5841F0F74}"/>
               </a:ext>
             </a:extLst>
           </p:cNvPr>
@@ -2680,7 +2680,7 @@
           <p:cNvPr id="15" name="object-15">
             <a:extLst>
               <a:ext uri="{FF2B5EF4-FFF2-40B4-BE49-F238E27FC236}">
-                <a16:creationId xmlns:a16="http://schemas.microsoft.com/office/drawing/2014/main" id="{451E6C7E-7FB2-41AC-BD6D-63EB3224AB23}"/>
+                <a16:creationId xmlns:a16="http://schemas.microsoft.com/office/drawing/2014/main" id="{7A76AE8F-C021-4151-9772-4DE7B58B76C2}"/>
               </a:ext>
             </a:extLst>
           </p:cNvPr>
@@ -2737,7 +2737,7 @@
           <p:cNvPr id="16" name="object-16">
             <a:extLst>
               <a:ext uri="{FF2B5EF4-FFF2-40B4-BE49-F238E27FC236}">
-                <a16:creationId xmlns:a16="http://schemas.microsoft.com/office/drawing/2014/main" id="{DA9A576A-C980-4C07-9AF8-363B55A611BA}"/>
+                <a16:creationId xmlns:a16="http://schemas.microsoft.com/office/drawing/2014/main" id="{A03A9461-2C43-44EB-A328-B801FDE172C5}"/>
               </a:ext>
             </a:extLst>
           </p:cNvPr>
@@ -2794,7 +2794,7 @@
           <p:cNvPr id="17" name="object-17">
             <a:extLst>
               <a:ext uri="{FF2B5EF4-FFF2-40B4-BE49-F238E27FC236}">
-                <a16:creationId xmlns:a16="http://schemas.microsoft.com/office/drawing/2014/main" id="{701C2C43-42F3-4CF9-BD9F-96335D6D7090}"/>
+                <a16:creationId xmlns:a16="http://schemas.microsoft.com/office/drawing/2014/main" id="{EAD8FCC3-C122-45CE-8C58-D429C7712EF8}"/>
               </a:ext>
             </a:extLst>
           </p:cNvPr>
@@ -2851,7 +2851,7 @@
           <p:cNvPr id="18" name="object-18">
             <a:extLst>
               <a:ext uri="{FF2B5EF4-FFF2-40B4-BE49-F238E27FC236}">
-                <a16:creationId xmlns:a16="http://schemas.microsoft.com/office/drawing/2014/main" id="{10BF0D46-32C6-4680-A23F-6867C4C9A180}"/>
+                <a16:creationId xmlns:a16="http://schemas.microsoft.com/office/drawing/2014/main" id="{44078CB7-E2A9-4164-B10B-AAF5E1002FFF}"/>
               </a:ext>
             </a:extLst>
           </p:cNvPr>
@@ -2908,7 +2908,7 @@
           <p:cNvPr id="19" name="object-19">
             <a:extLst>
               <a:ext uri="{FF2B5EF4-FFF2-40B4-BE49-F238E27FC236}">
-                <a16:creationId xmlns:a16="http://schemas.microsoft.com/office/drawing/2014/main" id="{1449AC12-987D-43C8-BFB0-6A531249EF72}"/>
+                <a16:creationId xmlns:a16="http://schemas.microsoft.com/office/drawing/2014/main" id="{5ED84715-4B0F-4380-AD8B-02688E880D55}"/>
               </a:ext>
             </a:extLst>
           </p:cNvPr>
@@ -2965,7 +2965,7 @@
           <p:cNvPr id="20" name="object-20">
             <a:extLst>
               <a:ext uri="{FF2B5EF4-FFF2-40B4-BE49-F238E27FC236}">
-                <a16:creationId xmlns:a16="http://schemas.microsoft.com/office/drawing/2014/main" id="{DDE5D93D-ABC7-4758-9EE2-B829E3E5B653}"/>
+                <a16:creationId xmlns:a16="http://schemas.microsoft.com/office/drawing/2014/main" id="{3D5E7042-DF90-4560-A417-33257A49507E}"/>
               </a:ext>
             </a:extLst>
           </p:cNvPr>
@@ -3022,7 +3022,7 @@
           <p:cNvPr id="21" name="object-21">
             <a:extLst>
               <a:ext uri="{FF2B5EF4-FFF2-40B4-BE49-F238E27FC236}">
-                <a16:creationId xmlns:a16="http://schemas.microsoft.com/office/drawing/2014/main" id="{71BA237C-6DF7-4F68-B0D5-37AE503EDDFE}"/>
+                <a16:creationId xmlns:a16="http://schemas.microsoft.com/office/drawing/2014/main" id="{9730D976-4D70-41FA-BAB9-2B02EE459D18}"/>
               </a:ext>
             </a:extLst>
           </p:cNvPr>
@@ -3079,7 +3079,7 @@
           <p:cNvPr id="22" name="object-22">
             <a:extLst>
               <a:ext uri="{FF2B5EF4-FFF2-40B4-BE49-F238E27FC236}">
-                <a16:creationId xmlns:a16="http://schemas.microsoft.com/office/drawing/2014/main" id="{95F57C3F-9767-472C-9A79-22DBBFCD1B31}"/>
+                <a16:creationId xmlns:a16="http://schemas.microsoft.com/office/drawing/2014/main" id="{FBB0CCAF-F0E3-4013-B6F6-45015755F287}"/>
               </a:ext>
             </a:extLst>
           </p:cNvPr>
@@ -3136,7 +3136,7 @@
           <p:cNvPr id="23" name="object-23">
             <a:extLst>
               <a:ext uri="{FF2B5EF4-FFF2-40B4-BE49-F238E27FC236}">
-                <a16:creationId xmlns:a16="http://schemas.microsoft.com/office/drawing/2014/main" id="{B26E40C6-D0AC-4968-9D4D-373288F65E89}"/>
+                <a16:creationId xmlns:a16="http://schemas.microsoft.com/office/drawing/2014/main" id="{B32F2FDB-3C93-4949-92FD-EAE6FE4B6D72}"/>
               </a:ext>
             </a:extLst>
           </p:cNvPr>
@@ -3193,7 +3193,7 @@
           <p:cNvPr id="24" name="object-24">
             <a:extLst>
               <a:ext uri="{FF2B5EF4-FFF2-40B4-BE49-F238E27FC236}">
-                <a16:creationId xmlns:a16="http://schemas.microsoft.com/office/drawing/2014/main" id="{18A1EDA1-D845-4566-9A50-0DA8F3C998C1}"/>
+                <a16:creationId xmlns:a16="http://schemas.microsoft.com/office/drawing/2014/main" id="{0A01558B-1FFA-4755-81A3-B23307141693}"/>
               </a:ext>
             </a:extLst>
           </p:cNvPr>
@@ -3250,7 +3250,7 @@
           <p:cNvPr id="25" name="object-25">
             <a:extLst>
               <a:ext uri="{FF2B5EF4-FFF2-40B4-BE49-F238E27FC236}">
-                <a16:creationId xmlns:a16="http://schemas.microsoft.com/office/drawing/2014/main" id="{25B9B8CD-062C-49AB-B7CD-BC88842E72A1}"/>
+                <a16:creationId xmlns:a16="http://schemas.microsoft.com/office/drawing/2014/main" id="{3CCA8114-41BA-459A-845A-F046F0490D5C}"/>
               </a:ext>
             </a:extLst>
           </p:cNvPr>
@@ -3307,7 +3307,7 @@
           <p:cNvPr id="26" name="object-26">
             <a:extLst>
               <a:ext uri="{FF2B5EF4-FFF2-40B4-BE49-F238E27FC236}">
-                <a16:creationId xmlns:a16="http://schemas.microsoft.com/office/drawing/2014/main" id="{4C3A1958-5B4A-4FA1-9C16-CE877D235A54}"/>
+                <a16:creationId xmlns:a16="http://schemas.microsoft.com/office/drawing/2014/main" id="{16C4127C-F161-45EA-BEB4-1644FF41CA67}"/>
               </a:ext>
             </a:extLst>
           </p:cNvPr>
@@ -3362,7 +3362,7 @@
     </p:spTree>
     <p:extLst>
       <p:ext uri="{BB962C8B-B14F-4D97-AF65-F5344CB8AC3E}">
-        <p14:creationId xmlns:p14="http://schemas.microsoft.com/office/powerpoint/2010/main" val="34304482"/>
+        <p14:creationId xmlns:p14="http://schemas.microsoft.com/office/powerpoint/2010/main" val="863919708"/>
       </p:ext>
     </p:extLst>
   </p:cSld>
@@ -3402,7 +3402,7 @@
           <p:cNvPr id="26" name="object-1">
             <a:extLst>
               <a:ext uri="{FF2B5EF4-FFF2-40B4-BE49-F238E27FC236}">
-                <a16:creationId xmlns:a16="http://schemas.microsoft.com/office/drawing/2014/main" id="{72C21344-DE96-4129-889D-4698A6B17E1E}"/>
+                <a16:creationId xmlns:a16="http://schemas.microsoft.com/office/drawing/2014/main" id="{961FD1A1-4DA9-40B4-AD6D-C7E1B2B5DF0E}"/>
               </a:ext>
             </a:extLst>
           </p:cNvPr>
@@ -3459,7 +3459,7 @@
           <p:cNvPr id="2" name="object-2">
             <a:extLst>
               <a:ext uri="{FF2B5EF4-FFF2-40B4-BE49-F238E27FC236}">
-                <a16:creationId xmlns:a16="http://schemas.microsoft.com/office/drawing/2014/main" id="{50DEDA65-5AD0-493D-B756-5002874B36C5}"/>
+                <a16:creationId xmlns:a16="http://schemas.microsoft.com/office/drawing/2014/main" id="{D040212B-CCB7-4D80-89FA-15949EBAD6AD}"/>
               </a:ext>
             </a:extLst>
           </p:cNvPr>
@@ -3516,7 +3516,7 @@
           <p:cNvPr id="3" name="object-3">
             <a:extLst>
               <a:ext uri="{FF2B5EF4-FFF2-40B4-BE49-F238E27FC236}">
-                <a16:creationId xmlns:a16="http://schemas.microsoft.com/office/drawing/2014/main" id="{C547D0D1-3E65-4683-B56C-8BF49248C7AA}"/>
+                <a16:creationId xmlns:a16="http://schemas.microsoft.com/office/drawing/2014/main" id="{57713C29-9B35-4180-918C-3EAD6ECE2199}"/>
               </a:ext>
             </a:extLst>
           </p:cNvPr>
@@ -3546,7 +3546,7 @@
           <p:cNvPr id="4" name="object-4">
             <a:extLst>
               <a:ext uri="{FF2B5EF4-FFF2-40B4-BE49-F238E27FC236}">
-                <a16:creationId xmlns:a16="http://schemas.microsoft.com/office/drawing/2014/main" id="{059AD014-9CBA-457C-8415-E8A3BF6D5DFD}"/>
+                <a16:creationId xmlns:a16="http://schemas.microsoft.com/office/drawing/2014/main" id="{807AAD7A-FBC1-4D52-A3BC-754291D95C02}"/>
               </a:ext>
             </a:extLst>
           </p:cNvPr>
@@ -3603,7 +3603,7 @@
           <p:cNvPr id="5" name="object-5">
             <a:extLst>
               <a:ext uri="{FF2B5EF4-FFF2-40B4-BE49-F238E27FC236}">
-                <a16:creationId xmlns:a16="http://schemas.microsoft.com/office/drawing/2014/main" id="{94A2AA0A-CC1E-4525-95F0-455494014F6C}"/>
+                <a16:creationId xmlns:a16="http://schemas.microsoft.com/office/drawing/2014/main" id="{0C1BB887-9C45-4464-A3C8-E0DA07AF94E7}"/>
               </a:ext>
             </a:extLst>
           </p:cNvPr>
@@ -3660,7 +3660,7 @@
           <p:cNvPr id="6" name="object-6">
             <a:extLst>
               <a:ext uri="{FF2B5EF4-FFF2-40B4-BE49-F238E27FC236}">
-                <a16:creationId xmlns:a16="http://schemas.microsoft.com/office/drawing/2014/main" id="{FF0992F8-8B1C-42F3-B340-ABA280277E8C}"/>
+                <a16:creationId xmlns:a16="http://schemas.microsoft.com/office/drawing/2014/main" id="{D8C27CC6-3C06-4C9F-843E-D804DCB00924}"/>
               </a:ext>
             </a:extLst>
           </p:cNvPr>
@@ -3717,7 +3717,7 @@
           <p:cNvPr id="7" name="object-7">
             <a:extLst>
               <a:ext uri="{FF2B5EF4-FFF2-40B4-BE49-F238E27FC236}">
-                <a16:creationId xmlns:a16="http://schemas.microsoft.com/office/drawing/2014/main" id="{537F4592-4973-4BF2-97D7-885F5EDD3B15}"/>
+                <a16:creationId xmlns:a16="http://schemas.microsoft.com/office/drawing/2014/main" id="{58D96876-4AA5-4774-8464-684F4CC3F323}"/>
               </a:ext>
             </a:extLst>
           </p:cNvPr>
@@ -3774,7 +3774,7 @@
           <p:cNvPr id="8" name="object-8">
             <a:extLst>
               <a:ext uri="{FF2B5EF4-FFF2-40B4-BE49-F238E27FC236}">
-                <a16:creationId xmlns:a16="http://schemas.microsoft.com/office/drawing/2014/main" id="{A5117FC4-AA47-43BD-B344-7B54A4270FEF}"/>
+                <a16:creationId xmlns:a16="http://schemas.microsoft.com/office/drawing/2014/main" id="{0F3F7A61-E21C-4F5A-B6F3-71B3EED24594}"/>
               </a:ext>
             </a:extLst>
           </p:cNvPr>
@@ -3831,7 +3831,7 @@
           <p:cNvPr id="9" name="object-9">
             <a:extLst>
               <a:ext uri="{FF2B5EF4-FFF2-40B4-BE49-F238E27FC236}">
-                <a16:creationId xmlns:a16="http://schemas.microsoft.com/office/drawing/2014/main" id="{A9932207-F91D-487F-9652-F4902B7FBBEF}"/>
+                <a16:creationId xmlns:a16="http://schemas.microsoft.com/office/drawing/2014/main" id="{4F2A0152-FBB7-42AB-A313-F79D6255F2C1}"/>
               </a:ext>
             </a:extLst>
           </p:cNvPr>
@@ -3888,7 +3888,7 @@
           <p:cNvPr id="10" name="object-10">
             <a:extLst>
               <a:ext uri="{FF2B5EF4-FFF2-40B4-BE49-F238E27FC236}">
-                <a16:creationId xmlns:a16="http://schemas.microsoft.com/office/drawing/2014/main" id="{725C0B62-AAF2-4F1B-839C-5A0602B2DA79}"/>
+                <a16:creationId xmlns:a16="http://schemas.microsoft.com/office/drawing/2014/main" id="{4BD7207F-9FDC-443C-B32E-4EF04CE072E1}"/>
               </a:ext>
             </a:extLst>
           </p:cNvPr>
@@ -3945,7 +3945,7 @@
           <p:cNvPr id="11" name="object-11">
             <a:extLst>
               <a:ext uri="{FF2B5EF4-FFF2-40B4-BE49-F238E27FC236}">
-                <a16:creationId xmlns:a16="http://schemas.microsoft.com/office/drawing/2014/main" id="{854D1CC4-3C8D-4A94-BDDF-3CB75089AD3F}"/>
+                <a16:creationId xmlns:a16="http://schemas.microsoft.com/office/drawing/2014/main" id="{A0DE0DA3-6A92-41A1-AC70-51394B42221B}"/>
               </a:ext>
             </a:extLst>
           </p:cNvPr>
@@ -4002,7 +4002,7 @@
           <p:cNvPr id="12" name="object-12">
             <a:extLst>
               <a:ext uri="{FF2B5EF4-FFF2-40B4-BE49-F238E27FC236}">
-                <a16:creationId xmlns:a16="http://schemas.microsoft.com/office/drawing/2014/main" id="{E1632870-928E-4DCA-9309-1A9522F1D434}"/>
+                <a16:creationId xmlns:a16="http://schemas.microsoft.com/office/drawing/2014/main" id="{8E918B3C-6187-401F-86FF-5F22443F09C2}"/>
               </a:ext>
             </a:extLst>
           </p:cNvPr>
@@ -4059,7 +4059,7 @@
           <p:cNvPr id="13" name="object-13">
             <a:extLst>
               <a:ext uri="{FF2B5EF4-FFF2-40B4-BE49-F238E27FC236}">
-                <a16:creationId xmlns:a16="http://schemas.microsoft.com/office/drawing/2014/main" id="{8CE18F04-B9EA-4B07-880E-38466A8D7EA0}"/>
+                <a16:creationId xmlns:a16="http://schemas.microsoft.com/office/drawing/2014/main" id="{F71A6F06-5FD2-418A-A4E7-1C5549DC1672}"/>
               </a:ext>
             </a:extLst>
           </p:cNvPr>
@@ -4116,7 +4116,7 @@
           <p:cNvPr id="14" name="object-14">
             <a:extLst>
               <a:ext uri="{FF2B5EF4-FFF2-40B4-BE49-F238E27FC236}">
-                <a16:creationId xmlns:a16="http://schemas.microsoft.com/office/drawing/2014/main" id="{67AACBFD-8913-4312-9C1E-8BB0323CC991}"/>
+                <a16:creationId xmlns:a16="http://schemas.microsoft.com/office/drawing/2014/main" id="{5E400342-86C1-4EB7-AA5E-9015B4A3BDCC}"/>
               </a:ext>
             </a:extLst>
           </p:cNvPr>
@@ -4173,7 +4173,7 @@
           <p:cNvPr id="15" name="object-15">
             <a:extLst>
               <a:ext uri="{FF2B5EF4-FFF2-40B4-BE49-F238E27FC236}">
-                <a16:creationId xmlns:a16="http://schemas.microsoft.com/office/drawing/2014/main" id="{2FE7270C-37C8-425C-9797-506DFCEBFA31}"/>
+                <a16:creationId xmlns:a16="http://schemas.microsoft.com/office/drawing/2014/main" id="{373A9FD4-7660-4E45-90DE-AA72E0A12D5B}"/>
               </a:ext>
             </a:extLst>
           </p:cNvPr>
@@ -4230,7 +4230,7 @@
           <p:cNvPr id="16" name="object-16">
             <a:extLst>
               <a:ext uri="{FF2B5EF4-FFF2-40B4-BE49-F238E27FC236}">
-                <a16:creationId xmlns:a16="http://schemas.microsoft.com/office/drawing/2014/main" id="{ED9D4149-BEF3-4EDE-8E6E-90C3A6F92E6F}"/>
+                <a16:creationId xmlns:a16="http://schemas.microsoft.com/office/drawing/2014/main" id="{EAF4B70D-D03B-4988-9D74-47BDFF0D3A7C}"/>
               </a:ext>
             </a:extLst>
           </p:cNvPr>
@@ -4287,7 +4287,7 @@
           <p:cNvPr id="17" name="object-17">
             <a:extLst>
               <a:ext uri="{FF2B5EF4-FFF2-40B4-BE49-F238E27FC236}">
-                <a16:creationId xmlns:a16="http://schemas.microsoft.com/office/drawing/2014/main" id="{3B12ED83-DA42-46E0-A8D3-5DBE7CFC3DBF}"/>
+                <a16:creationId xmlns:a16="http://schemas.microsoft.com/office/drawing/2014/main" id="{8B16B767-C42C-4334-8BA6-25ED50212675}"/>
               </a:ext>
             </a:extLst>
           </p:cNvPr>
@@ -4344,7 +4344,7 @@
           <p:cNvPr id="18" name="object-18">
             <a:extLst>
               <a:ext uri="{FF2B5EF4-FFF2-40B4-BE49-F238E27FC236}">
-                <a16:creationId xmlns:a16="http://schemas.microsoft.com/office/drawing/2014/main" id="{6A6C43B9-10F1-4B96-AE8C-1F2CCB9DA602}"/>
+                <a16:creationId xmlns:a16="http://schemas.microsoft.com/office/drawing/2014/main" id="{D2562302-890E-4B14-A628-C0AD5BDF656A}"/>
               </a:ext>
             </a:extLst>
           </p:cNvPr>
@@ -4401,7 +4401,7 @@
           <p:cNvPr id="19" name="object-19">
             <a:extLst>
               <a:ext uri="{FF2B5EF4-FFF2-40B4-BE49-F238E27FC236}">
-                <a16:creationId xmlns:a16="http://schemas.microsoft.com/office/drawing/2014/main" id="{22D94359-D504-4AB9-9261-9B8A9CC88EBD}"/>
+                <a16:creationId xmlns:a16="http://schemas.microsoft.com/office/drawing/2014/main" id="{325FC545-4494-4ECE-A853-5DFCBDC874D0}"/>
               </a:ext>
             </a:extLst>
           </p:cNvPr>
@@ -4458,7 +4458,7 @@
           <p:cNvPr id="20" name="object-20">
             <a:extLst>
               <a:ext uri="{FF2B5EF4-FFF2-40B4-BE49-F238E27FC236}">
-                <a16:creationId xmlns:a16="http://schemas.microsoft.com/office/drawing/2014/main" id="{D544FBCD-7611-4A2C-95F4-863950BADC75}"/>
+                <a16:creationId xmlns:a16="http://schemas.microsoft.com/office/drawing/2014/main" id="{235FB35E-DDD2-4218-BDF2-8A2A9D2739EF}"/>
               </a:ext>
             </a:extLst>
           </p:cNvPr>
@@ -4515,7 +4515,7 @@
           <p:cNvPr id="21" name="object-21">
             <a:extLst>
               <a:ext uri="{FF2B5EF4-FFF2-40B4-BE49-F238E27FC236}">
-                <a16:creationId xmlns:a16="http://schemas.microsoft.com/office/drawing/2014/main" id="{756B585E-33D8-4DBF-BE2B-57795546E927}"/>
+                <a16:creationId xmlns:a16="http://schemas.microsoft.com/office/drawing/2014/main" id="{9ED670FA-4D9E-4818-B061-6702E0BF742B}"/>
               </a:ext>
             </a:extLst>
           </p:cNvPr>
@@ -4572,7 +4572,7 @@
           <p:cNvPr id="22" name="object-22">
             <a:extLst>
               <a:ext uri="{FF2B5EF4-FFF2-40B4-BE49-F238E27FC236}">
-                <a16:creationId xmlns:a16="http://schemas.microsoft.com/office/drawing/2014/main" id="{479A28CA-0395-4533-B66A-E2FC872AC609}"/>
+                <a16:creationId xmlns:a16="http://schemas.microsoft.com/office/drawing/2014/main" id="{9BA1BE68-D35E-47DA-A801-B2C1F9D97E1B}"/>
               </a:ext>
             </a:extLst>
           </p:cNvPr>
@@ -4629,7 +4629,7 @@
           <p:cNvPr id="23" name="object-23">
             <a:extLst>
               <a:ext uri="{FF2B5EF4-FFF2-40B4-BE49-F238E27FC236}">
-                <a16:creationId xmlns:a16="http://schemas.microsoft.com/office/drawing/2014/main" id="{22903893-A624-46E6-A89A-F8BBFEC69AFB}"/>
+                <a16:creationId xmlns:a16="http://schemas.microsoft.com/office/drawing/2014/main" id="{3AD3C794-BE0C-44C0-AB8E-C5B64B2540B6}"/>
               </a:ext>
             </a:extLst>
           </p:cNvPr>
@@ -4686,7 +4686,7 @@
           <p:cNvPr id="24" name="object-24">
             <a:extLst>
               <a:ext uri="{FF2B5EF4-FFF2-40B4-BE49-F238E27FC236}">
-                <a16:creationId xmlns:a16="http://schemas.microsoft.com/office/drawing/2014/main" id="{E2EE7744-A410-48E3-BFF6-DD7F2CE80D3A}"/>
+                <a16:creationId xmlns:a16="http://schemas.microsoft.com/office/drawing/2014/main" id="{8C8ECA26-8BF4-43DC-95AE-91488F4079F4}"/>
               </a:ext>
             </a:extLst>
           </p:cNvPr>
@@ -4743,7 +4743,7 @@
           <p:cNvPr id="25" name="object-25">
             <a:extLst>
               <a:ext uri="{FF2B5EF4-FFF2-40B4-BE49-F238E27FC236}">
-                <a16:creationId xmlns:a16="http://schemas.microsoft.com/office/drawing/2014/main" id="{236FE730-7141-4BE2-B8DE-36A9D04ED70F}"/>
+                <a16:creationId xmlns:a16="http://schemas.microsoft.com/office/drawing/2014/main" id="{A9830A20-259F-4FBC-89F3-D3F3416498FF}"/>
               </a:ext>
             </a:extLst>
           </p:cNvPr>
@@ -4798,7 +4798,7 @@
     </p:spTree>
     <p:extLst>
       <p:ext uri="{BB962C8B-B14F-4D97-AF65-F5344CB8AC3E}">
-        <p14:creationId xmlns:p14="http://schemas.microsoft.com/office/powerpoint/2010/main" val="361442265"/>
+        <p14:creationId xmlns:p14="http://schemas.microsoft.com/office/powerpoint/2010/main" val="1534689649"/>
       </p:ext>
     </p:extLst>
   </p:cSld>
@@ -4838,7 +4838,7 @@
           <p:cNvPr id="12" name="object-1">
             <a:extLst>
               <a:ext uri="{FF2B5EF4-FFF2-40B4-BE49-F238E27FC236}">
-                <a16:creationId xmlns:a16="http://schemas.microsoft.com/office/drawing/2014/main" id="{A92B9B57-1D03-47D5-BACB-F92F39AAE386}"/>
+                <a16:creationId xmlns:a16="http://schemas.microsoft.com/office/drawing/2014/main" id="{887DE91C-169A-4E1F-994E-582E753575C5}"/>
               </a:ext>
             </a:extLst>
           </p:cNvPr>
@@ -4895,7 +4895,7 @@
           <p:cNvPr id="2" name="object-2">
             <a:extLst>
               <a:ext uri="{FF2B5EF4-FFF2-40B4-BE49-F238E27FC236}">
-                <a16:creationId xmlns:a16="http://schemas.microsoft.com/office/drawing/2014/main" id="{B3CC5D53-D04C-40D1-BDCC-D2B2D272ADC4}"/>
+                <a16:creationId xmlns:a16="http://schemas.microsoft.com/office/drawing/2014/main" id="{8253B391-A940-49D6-8A07-979F307FB8DA}"/>
               </a:ext>
             </a:extLst>
           </p:cNvPr>
@@ -4942,7 +4942,7 @@
                 <a:ea typeface="Arial"/>
                 <a:cs typeface="Arial"/>
               </a:rPr>
-              <a:t>Find 15% of 240.</a:t>
+              <a:t>Increase 240 by 15%.</a:t>
             </a:r>
           </a:p>
         </p:txBody>
@@ -4952,7 +4952,7 @@
           <p:cNvPr id="3" name="object-3">
             <a:extLst>
               <a:ext uri="{FF2B5EF4-FFF2-40B4-BE49-F238E27FC236}">
-                <a16:creationId xmlns:a16="http://schemas.microsoft.com/office/drawing/2014/main" id="{CC6EAB8D-7318-477D-A975-D8104B4CEC1B}"/>
+                <a16:creationId xmlns:a16="http://schemas.microsoft.com/office/drawing/2014/main" id="{EB0B3988-6175-4D94-85D9-135CB5FF83FC}"/>
               </a:ext>
             </a:extLst>
           </p:cNvPr>
@@ -4982,7 +4982,7 @@
           <p:cNvPr id="4" name="object-4">
             <a:extLst>
               <a:ext uri="{FF2B5EF4-FFF2-40B4-BE49-F238E27FC236}">
-                <a16:creationId xmlns:a16="http://schemas.microsoft.com/office/drawing/2014/main" id="{D7672BD1-F6E1-4855-B94A-471E1DA08891}"/>
+                <a16:creationId xmlns:a16="http://schemas.microsoft.com/office/drawing/2014/main" id="{BE196BC2-C0AA-4FB5-8626-855E4DE801CF}"/>
               </a:ext>
             </a:extLst>
           </p:cNvPr>
@@ -5039,7 +5039,7 @@
           <p:cNvPr id="5" name="object-5">
             <a:extLst>
               <a:ext uri="{FF2B5EF4-FFF2-40B4-BE49-F238E27FC236}">
-                <a16:creationId xmlns:a16="http://schemas.microsoft.com/office/drawing/2014/main" id="{4C387E4A-1C83-451B-8F8D-026372BDF471}"/>
+                <a16:creationId xmlns:a16="http://schemas.microsoft.com/office/drawing/2014/main" id="{5EF5FE30-0E94-4E4D-9E91-250E1C5E8442}"/>
               </a:ext>
             </a:extLst>
           </p:cNvPr>
@@ -5096,7 +5096,7 @@
           <p:cNvPr id="6" name="object-6">
             <a:extLst>
               <a:ext uri="{FF2B5EF4-FFF2-40B4-BE49-F238E27FC236}">
-                <a16:creationId xmlns:a16="http://schemas.microsoft.com/office/drawing/2014/main" id="{9C40CD6A-F330-4702-B73F-F5D88BCCDAD3}"/>
+                <a16:creationId xmlns:a16="http://schemas.microsoft.com/office/drawing/2014/main" id="{9F8394BE-F47C-47C4-80EA-CCB2D37D0596}"/>
               </a:ext>
             </a:extLst>
           </p:cNvPr>
@@ -5128,7 +5128,7 @@
           <p:cNvPr id="7" name="object-7">
             <a:extLst>
               <a:ext uri="{FF2B5EF4-FFF2-40B4-BE49-F238E27FC236}">
-                <a16:creationId xmlns:a16="http://schemas.microsoft.com/office/drawing/2014/main" id="{36FA854D-D344-4BBF-874E-260B62C06AB4}"/>
+                <a16:creationId xmlns:a16="http://schemas.microsoft.com/office/drawing/2014/main" id="{61345F5E-AB22-420F-BD3D-D25D16E78EEC}"/>
               </a:ext>
             </a:extLst>
           </p:cNvPr>
@@ -5158,7 +5158,7 @@
           <p:cNvPr id="8" name="object-8">
             <a:extLst>
               <a:ext uri="{FF2B5EF4-FFF2-40B4-BE49-F238E27FC236}">
-                <a16:creationId xmlns:a16="http://schemas.microsoft.com/office/drawing/2014/main" id="{8D2708AA-4363-4DFE-9E9E-097A8B956B7F}"/>
+                <a16:creationId xmlns:a16="http://schemas.microsoft.com/office/drawing/2014/main" id="{0374B5BB-9EEC-45F2-9536-8CB6C4F45852}"/>
               </a:ext>
             </a:extLst>
           </p:cNvPr>
@@ -5215,7 +5215,7 @@
           <p:cNvPr id="9" name="object-9">
             <a:extLst>
               <a:ext uri="{FF2B5EF4-FFF2-40B4-BE49-F238E27FC236}">
-                <a16:creationId xmlns:a16="http://schemas.microsoft.com/office/drawing/2014/main" id="{4DA7225D-9851-4B36-9AEB-8BEE9D0CEE02}"/>
+                <a16:creationId xmlns:a16="http://schemas.microsoft.com/office/drawing/2014/main" id="{61BAF0AA-5F78-44A1-B87C-ADFD88993659}"/>
               </a:ext>
             </a:extLst>
           </p:cNvPr>
@@ -5272,7 +5272,7 @@
           <p:cNvPr id="10" name="object-10">
             <a:extLst>
               <a:ext uri="{FF2B5EF4-FFF2-40B4-BE49-F238E27FC236}">
-                <a16:creationId xmlns:a16="http://schemas.microsoft.com/office/drawing/2014/main" id="{9FE84018-9257-4F2B-9B82-EAEFD7CF9BAB}"/>
+                <a16:creationId xmlns:a16="http://schemas.microsoft.com/office/drawing/2014/main" id="{4D2AF716-1AAF-4FB7-A9DD-A6DBE0021D7B}"/>
               </a:ext>
             </a:extLst>
           </p:cNvPr>
@@ -5329,7 +5329,7 @@
           <p:cNvPr id="11" name="object-11">
             <a:extLst>
               <a:ext uri="{FF2B5EF4-FFF2-40B4-BE49-F238E27FC236}">
-                <a16:creationId xmlns:a16="http://schemas.microsoft.com/office/drawing/2014/main" id="{66560EA7-6F24-478E-8133-5E87F857CFFF}"/>
+                <a16:creationId xmlns:a16="http://schemas.microsoft.com/office/drawing/2014/main" id="{953FF6DB-E44B-45E0-8543-E45382083B18}"/>
               </a:ext>
             </a:extLst>
           </p:cNvPr>
@@ -5376,7 +5376,7 @@
                 <a:ea typeface="Arial"/>
                 <a:cs typeface="Arial"/>
               </a:rPr>
-              <a:t>2.4 × 15 = 36</a:t>
+              <a:t>240 + 36 = 276</a:t>
             </a:r>
           </a:p>
         </p:txBody>
@@ -5384,7 +5384,7 @@
     </p:spTree>
     <p:extLst>
       <p:ext uri="{BB962C8B-B14F-4D97-AF65-F5344CB8AC3E}">
-        <p14:creationId xmlns:p14="http://schemas.microsoft.com/office/powerpoint/2010/main" val="210721622"/>
+        <p14:creationId xmlns:p14="http://schemas.microsoft.com/office/powerpoint/2010/main" val="73871863"/>
       </p:ext>
     </p:extLst>
   </p:cSld>
@@ -5621,7 +5621,7 @@
           <p:cNvPr id="12" name="object-1">
             <a:extLst>
               <a:ext uri="{FF2B5EF4-FFF2-40B4-BE49-F238E27FC236}">
-                <a16:creationId xmlns:a16="http://schemas.microsoft.com/office/drawing/2014/main" id="{95B70DA9-F484-4B44-8B88-AF56004914D7}"/>
+                <a16:creationId xmlns:a16="http://schemas.microsoft.com/office/drawing/2014/main" id="{A635C4D8-9B16-4D0E-9D11-A52BF892151A}"/>
               </a:ext>
             </a:extLst>
           </p:cNvPr>
@@ -5678,7 +5678,7 @@
           <p:cNvPr id="2" name="object-2">
             <a:extLst>
               <a:ext uri="{FF2B5EF4-FFF2-40B4-BE49-F238E27FC236}">
-                <a16:creationId xmlns:a16="http://schemas.microsoft.com/office/drawing/2014/main" id="{2A97256E-1286-4CFA-8EC6-42006B71D506}"/>
+                <a16:creationId xmlns:a16="http://schemas.microsoft.com/office/drawing/2014/main" id="{B9826499-8822-43AE-8C2E-F6A1FFED81AE}"/>
               </a:ext>
             </a:extLst>
           </p:cNvPr>
@@ -5735,7 +5735,7 @@
           <p:cNvPr id="3" name="object-3">
             <a:extLst>
               <a:ext uri="{FF2B5EF4-FFF2-40B4-BE49-F238E27FC236}">
-                <a16:creationId xmlns:a16="http://schemas.microsoft.com/office/drawing/2014/main" id="{4530799E-F567-4777-95DC-3305FA4FF320}"/>
+                <a16:creationId xmlns:a16="http://schemas.microsoft.com/office/drawing/2014/main" id="{87AA04F2-16AE-4AC2-BE6F-4457E69B15FE}"/>
               </a:ext>
             </a:extLst>
           </p:cNvPr>
@@ -5765,7 +5765,7 @@
           <p:cNvPr id="4" name="object-4">
             <a:extLst>
               <a:ext uri="{FF2B5EF4-FFF2-40B4-BE49-F238E27FC236}">
-                <a16:creationId xmlns:a16="http://schemas.microsoft.com/office/drawing/2014/main" id="{5AA9FE1D-F0FB-4FBE-92C6-BA518D5D9D57}"/>
+                <a16:creationId xmlns:a16="http://schemas.microsoft.com/office/drawing/2014/main" id="{61BC2FF8-5D25-40CD-A1A1-805B19719907}"/>
               </a:ext>
             </a:extLst>
           </p:cNvPr>
@@ -5822,7 +5822,7 @@
           <p:cNvPr id="5" name="object-5">
             <a:extLst>
               <a:ext uri="{FF2B5EF4-FFF2-40B4-BE49-F238E27FC236}">
-                <a16:creationId xmlns:a16="http://schemas.microsoft.com/office/drawing/2014/main" id="{01A02D1D-AB20-4086-ACFF-201B9D8D13BA}"/>
+                <a16:creationId xmlns:a16="http://schemas.microsoft.com/office/drawing/2014/main" id="{3A8FF4B4-7F28-47A5-ABA1-2C983C777B36}"/>
               </a:ext>
             </a:extLst>
           </p:cNvPr>
@@ -5879,7 +5879,7 @@
           <p:cNvPr id="6" name="object-6">
             <a:extLst>
               <a:ext uri="{FF2B5EF4-FFF2-40B4-BE49-F238E27FC236}">
-                <a16:creationId xmlns:a16="http://schemas.microsoft.com/office/drawing/2014/main" id="{B9D2154A-DDDB-4CC2-A960-A4DD569D45C3}"/>
+                <a16:creationId xmlns:a16="http://schemas.microsoft.com/office/drawing/2014/main" id="{D8E1F58D-542E-49C1-80C9-3B0640170306}"/>
               </a:ext>
             </a:extLst>
           </p:cNvPr>
@@ -5911,7 +5911,7 @@
           <p:cNvPr id="7" name="object-7">
             <a:extLst>
               <a:ext uri="{FF2B5EF4-FFF2-40B4-BE49-F238E27FC236}">
-                <a16:creationId xmlns:a16="http://schemas.microsoft.com/office/drawing/2014/main" id="{7E9F5EAE-75DF-439C-8508-E3F1296D8E2C}"/>
+                <a16:creationId xmlns:a16="http://schemas.microsoft.com/office/drawing/2014/main" id="{88426BBB-6E42-4E43-96B4-125C81561537}"/>
               </a:ext>
             </a:extLst>
           </p:cNvPr>
@@ -5941,7 +5941,7 @@
           <p:cNvPr id="8" name="object-8">
             <a:extLst>
               <a:ext uri="{FF2B5EF4-FFF2-40B4-BE49-F238E27FC236}">
-                <a16:creationId xmlns:a16="http://schemas.microsoft.com/office/drawing/2014/main" id="{02BA35C0-2922-4A0B-A1C2-DCEECBAC9C7E}"/>
+                <a16:creationId xmlns:a16="http://schemas.microsoft.com/office/drawing/2014/main" id="{AE5DE529-821F-4582-90CE-99A652610A9A}"/>
               </a:ext>
             </a:extLst>
           </p:cNvPr>
@@ -5998,7 +5998,7 @@
           <p:cNvPr id="9" name="object-9">
             <a:extLst>
               <a:ext uri="{FF2B5EF4-FFF2-40B4-BE49-F238E27FC236}">
-                <a16:creationId xmlns:a16="http://schemas.microsoft.com/office/drawing/2014/main" id="{D8DEA610-CC31-4DA2-B692-C5C731B05955}"/>
+                <a16:creationId xmlns:a16="http://schemas.microsoft.com/office/drawing/2014/main" id="{F136E7E6-8143-4142-B838-F05F7B844CDE}"/>
               </a:ext>
             </a:extLst>
           </p:cNvPr>
@@ -6055,7 +6055,7 @@
           <p:cNvPr id="10" name="object-10">
             <a:extLst>
               <a:ext uri="{FF2B5EF4-FFF2-40B4-BE49-F238E27FC236}">
-                <a16:creationId xmlns:a16="http://schemas.microsoft.com/office/drawing/2014/main" id="{4C4453B2-5EFB-4EF2-BEBE-69DB3B6ABD6C}"/>
+                <a16:creationId xmlns:a16="http://schemas.microsoft.com/office/drawing/2014/main" id="{35062BA7-BD89-4F3A-BE6E-D2C3EAE2A61F}"/>
               </a:ext>
             </a:extLst>
           </p:cNvPr>
@@ -6112,7 +6112,7 @@
           <p:cNvPr id="11" name="object-11">
             <a:extLst>
               <a:ext uri="{FF2B5EF4-FFF2-40B4-BE49-F238E27FC236}">
-                <a16:creationId xmlns:a16="http://schemas.microsoft.com/office/drawing/2014/main" id="{11A0C414-1B6C-4037-A212-B2E048688ABF}"/>
+                <a16:creationId xmlns:a16="http://schemas.microsoft.com/office/drawing/2014/main" id="{67D6FD10-ABF4-48B7-8469-C5E01D77E4CC}"/>
               </a:ext>
             </a:extLst>
           </p:cNvPr>
@@ -6167,7 +6167,7 @@
     </p:spTree>
     <p:extLst>
       <p:ext uri="{BB962C8B-B14F-4D97-AF65-F5344CB8AC3E}">
-        <p14:creationId xmlns:p14="http://schemas.microsoft.com/office/powerpoint/2010/main" val="376490876"/>
+        <p14:creationId xmlns:p14="http://schemas.microsoft.com/office/powerpoint/2010/main" val="1212521534"/>
       </p:ext>
     </p:extLst>
   </p:cSld>
@@ -6404,7 +6404,7 @@
           <p:cNvPr id="13" name="object-1">
             <a:extLst>
               <a:ext uri="{FF2B5EF4-FFF2-40B4-BE49-F238E27FC236}">
-                <a16:creationId xmlns:a16="http://schemas.microsoft.com/office/drawing/2014/main" id="{8D597C71-5158-4B13-9207-113A34D7B4CF}"/>
+                <a16:creationId xmlns:a16="http://schemas.microsoft.com/office/drawing/2014/main" id="{0B260BD5-D66A-4813-895C-5E5AF938C3BE}"/>
               </a:ext>
             </a:extLst>
           </p:cNvPr>
@@ -6461,7 +6461,7 @@
           <p:cNvPr id="2" name="object-2">
             <a:extLst>
               <a:ext uri="{FF2B5EF4-FFF2-40B4-BE49-F238E27FC236}">
-                <a16:creationId xmlns:a16="http://schemas.microsoft.com/office/drawing/2014/main" id="{133BA349-78A9-4D45-9259-DAD168F2FA4A}"/>
+                <a16:creationId xmlns:a16="http://schemas.microsoft.com/office/drawing/2014/main" id="{27509159-3A08-4D11-89CE-8970D82C43B8}"/>
               </a:ext>
             </a:extLst>
           </p:cNvPr>
@@ -6518,7 +6518,7 @@
           <p:cNvPr id="3" name="object-3">
             <a:extLst>
               <a:ext uri="{FF2B5EF4-FFF2-40B4-BE49-F238E27FC236}">
-                <a16:creationId xmlns:a16="http://schemas.microsoft.com/office/drawing/2014/main" id="{C9637EFD-9DF3-4415-B2F2-9B822A11C900}"/>
+                <a16:creationId xmlns:a16="http://schemas.microsoft.com/office/drawing/2014/main" id="{85AA89FF-D1AF-4DE3-9A62-EA70AAAC0B5C}"/>
               </a:ext>
             </a:extLst>
           </p:cNvPr>
@@ -6565,7 +6565,7 @@
                 <a:ea typeface="Arial"/>
                 <a:cs typeface="Arial"/>
               </a:rPr>
-              <a:t>Find 15% of 340.</a:t>
+              <a:t>Increase 340 by 15%.</a:t>
             </a:r>
           </a:p>
         </p:txBody>
@@ -6575,7 +6575,7 @@
           <p:cNvPr id="4" name="object-4">
             <a:extLst>
               <a:ext uri="{FF2B5EF4-FFF2-40B4-BE49-F238E27FC236}">
-                <a16:creationId xmlns:a16="http://schemas.microsoft.com/office/drawing/2014/main" id="{8DCFF069-F8B3-4C4D-8784-41D957539ED5}"/>
+                <a16:creationId xmlns:a16="http://schemas.microsoft.com/office/drawing/2014/main" id="{63E56DDB-B70A-4545-B9B7-E45589250C3F}"/>
               </a:ext>
             </a:extLst>
           </p:cNvPr>
@@ -6605,7 +6605,7 @@
           <p:cNvPr id="5" name="object-5">
             <a:extLst>
               <a:ext uri="{FF2B5EF4-FFF2-40B4-BE49-F238E27FC236}">
-                <a16:creationId xmlns:a16="http://schemas.microsoft.com/office/drawing/2014/main" id="{C801AED7-7694-4C40-9DD4-EEABA6690281}"/>
+                <a16:creationId xmlns:a16="http://schemas.microsoft.com/office/drawing/2014/main" id="{80D971F0-43A7-4D81-A8A3-59B141D3BAB8}"/>
               </a:ext>
             </a:extLst>
           </p:cNvPr>
@@ -6662,7 +6662,7 @@
           <p:cNvPr id="6" name="object-6">
             <a:extLst>
               <a:ext uri="{FF2B5EF4-FFF2-40B4-BE49-F238E27FC236}">
-                <a16:creationId xmlns:a16="http://schemas.microsoft.com/office/drawing/2014/main" id="{4D55C48D-8D50-4DFE-83AA-A3886F4CC0C6}"/>
+                <a16:creationId xmlns:a16="http://schemas.microsoft.com/office/drawing/2014/main" id="{67DC234C-12A4-4090-879F-1C44867062C6}"/>
               </a:ext>
             </a:extLst>
           </p:cNvPr>
@@ -6719,7 +6719,7 @@
           <p:cNvPr id="7" name="object-7">
             <a:extLst>
               <a:ext uri="{FF2B5EF4-FFF2-40B4-BE49-F238E27FC236}">
-                <a16:creationId xmlns:a16="http://schemas.microsoft.com/office/drawing/2014/main" id="{33A814F5-5DF4-48DE-A730-F70075FAAB50}"/>
+                <a16:creationId xmlns:a16="http://schemas.microsoft.com/office/drawing/2014/main" id="{9ED251B0-C8A6-40B7-BE23-03ABC96A0CD6}"/>
               </a:ext>
             </a:extLst>
           </p:cNvPr>
@@ -6751,7 +6751,7 @@
           <p:cNvPr id="8" name="object-8">
             <a:extLst>
               <a:ext uri="{FF2B5EF4-FFF2-40B4-BE49-F238E27FC236}">
-                <a16:creationId xmlns:a16="http://schemas.microsoft.com/office/drawing/2014/main" id="{53170B26-2517-464A-93C6-A0B6ACFCB7D4}"/>
+                <a16:creationId xmlns:a16="http://schemas.microsoft.com/office/drawing/2014/main" id="{3C1712E6-B483-41AC-A227-0899C0BFF93F}"/>
               </a:ext>
             </a:extLst>
           </p:cNvPr>
@@ -6781,7 +6781,7 @@
           <p:cNvPr id="9" name="object-9">
             <a:extLst>
               <a:ext uri="{FF2B5EF4-FFF2-40B4-BE49-F238E27FC236}">
-                <a16:creationId xmlns:a16="http://schemas.microsoft.com/office/drawing/2014/main" id="{0FFB44C6-029D-4E92-B625-0C387A8935F3}"/>
+                <a16:creationId xmlns:a16="http://schemas.microsoft.com/office/drawing/2014/main" id="{D4A193CC-F80B-4ADA-9C4A-7E1CC74EE47A}"/>
               </a:ext>
             </a:extLst>
           </p:cNvPr>
@@ -6838,7 +6838,7 @@
           <p:cNvPr id="10" name="object-10">
             <a:extLst>
               <a:ext uri="{FF2B5EF4-FFF2-40B4-BE49-F238E27FC236}">
-                <a16:creationId xmlns:a16="http://schemas.microsoft.com/office/drawing/2014/main" id="{20E9399A-EAF7-4DBD-A935-EB5C27FC7941}"/>
+                <a16:creationId xmlns:a16="http://schemas.microsoft.com/office/drawing/2014/main" id="{EA2285B7-1E4E-4A21-B12D-D8F5AC87B21D}"/>
               </a:ext>
             </a:extLst>
           </p:cNvPr>
@@ -6895,7 +6895,7 @@
           <p:cNvPr id="11" name="object-11">
             <a:extLst>
               <a:ext uri="{FF2B5EF4-FFF2-40B4-BE49-F238E27FC236}">
-                <a16:creationId xmlns:a16="http://schemas.microsoft.com/office/drawing/2014/main" id="{3570AB74-8EEC-4CB5-9651-F28ABFFF62C7}"/>
+                <a16:creationId xmlns:a16="http://schemas.microsoft.com/office/drawing/2014/main" id="{20E3DBD1-A2F0-4ABD-9D48-64490CD37D64}"/>
               </a:ext>
             </a:extLst>
           </p:cNvPr>
@@ -6952,7 +6952,7 @@
           <p:cNvPr id="12" name="object-12">
             <a:extLst>
               <a:ext uri="{FF2B5EF4-FFF2-40B4-BE49-F238E27FC236}">
-                <a16:creationId xmlns:a16="http://schemas.microsoft.com/office/drawing/2014/main" id="{6B84672A-E045-465F-89D5-B419374A1C16}"/>
+                <a16:creationId xmlns:a16="http://schemas.microsoft.com/office/drawing/2014/main" id="{23A6140E-156B-44A7-89A4-155FB65F3C03}"/>
               </a:ext>
             </a:extLst>
           </p:cNvPr>
@@ -6999,7 +6999,7 @@
                 <a:ea typeface="Arial"/>
                 <a:cs typeface="Arial"/>
               </a:rPr>
-              <a:t>3.4 × 15 = 51</a:t>
+              <a:t>340 + 51 = 391</a:t>
             </a:r>
           </a:p>
         </p:txBody>
@@ -7007,7 +7007,7 @@
     </p:spTree>
     <p:extLst>
       <p:ext uri="{BB962C8B-B14F-4D97-AF65-F5344CB8AC3E}">
-        <p14:creationId xmlns:p14="http://schemas.microsoft.com/office/powerpoint/2010/main" val="1610502793"/>
+        <p14:creationId xmlns:p14="http://schemas.microsoft.com/office/powerpoint/2010/main" val="968642026"/>
       </p:ext>
     </p:extLst>
   </p:cSld>
@@ -7244,7 +7244,7 @@
           <p:cNvPr id="13" name="object-1">
             <a:extLst>
               <a:ext uri="{FF2B5EF4-FFF2-40B4-BE49-F238E27FC236}">
-                <a16:creationId xmlns:a16="http://schemas.microsoft.com/office/drawing/2014/main" id="{73A03D91-50D2-4AF2-8CFB-E1FCF243ADD1}"/>
+                <a16:creationId xmlns:a16="http://schemas.microsoft.com/office/drawing/2014/main" id="{D8A67735-BEA5-4792-9ED8-5BFFC439D4D7}"/>
               </a:ext>
             </a:extLst>
           </p:cNvPr>
@@ -7301,7 +7301,7 @@
           <p:cNvPr id="2" name="object-2">
             <a:extLst>
               <a:ext uri="{FF2B5EF4-FFF2-40B4-BE49-F238E27FC236}">
-                <a16:creationId xmlns:a16="http://schemas.microsoft.com/office/drawing/2014/main" id="{B3C8DC31-3305-4CB0-9D21-F39636C062AD}"/>
+                <a16:creationId xmlns:a16="http://schemas.microsoft.com/office/drawing/2014/main" id="{D4892E3C-20E4-4BE7-ACD1-32A4CC165E89}"/>
               </a:ext>
             </a:extLst>
           </p:cNvPr>
@@ -7358,7 +7358,7 @@
           <p:cNvPr id="3" name="object-3">
             <a:extLst>
               <a:ext uri="{FF2B5EF4-FFF2-40B4-BE49-F238E27FC236}">
-                <a16:creationId xmlns:a16="http://schemas.microsoft.com/office/drawing/2014/main" id="{5BBCB164-6C9B-4B80-918A-344D8196BEF8}"/>
+                <a16:creationId xmlns:a16="http://schemas.microsoft.com/office/drawing/2014/main" id="{1780FB84-D119-4E80-B96C-637CA0B14AD4}"/>
               </a:ext>
             </a:extLst>
           </p:cNvPr>
@@ -7415,7 +7415,7 @@
           <p:cNvPr id="4" name="object-4">
             <a:extLst>
               <a:ext uri="{FF2B5EF4-FFF2-40B4-BE49-F238E27FC236}">
-                <a16:creationId xmlns:a16="http://schemas.microsoft.com/office/drawing/2014/main" id="{1F0DBC13-CDB2-488F-913E-E8B68D9EF31C}"/>
+                <a16:creationId xmlns:a16="http://schemas.microsoft.com/office/drawing/2014/main" id="{B6F8FDAD-8FB2-43D8-A4A9-BCB88D9C7C45}"/>
               </a:ext>
             </a:extLst>
           </p:cNvPr>
@@ -7445,7 +7445,7 @@
           <p:cNvPr id="5" name="object-5">
             <a:extLst>
               <a:ext uri="{FF2B5EF4-FFF2-40B4-BE49-F238E27FC236}">
-                <a16:creationId xmlns:a16="http://schemas.microsoft.com/office/drawing/2014/main" id="{65ECA1A4-F1E7-461D-9619-BCDDA4DF330C}"/>
+                <a16:creationId xmlns:a16="http://schemas.microsoft.com/office/drawing/2014/main" id="{8A37EFDF-2C6B-43B4-9966-92D8384242D4}"/>
               </a:ext>
             </a:extLst>
           </p:cNvPr>
@@ -7502,7 +7502,7 @@
           <p:cNvPr id="6" name="object-6">
             <a:extLst>
               <a:ext uri="{FF2B5EF4-FFF2-40B4-BE49-F238E27FC236}">
-                <a16:creationId xmlns:a16="http://schemas.microsoft.com/office/drawing/2014/main" id="{C5421A77-D2D6-4603-B14F-C4F17C2E5745}"/>
+                <a16:creationId xmlns:a16="http://schemas.microsoft.com/office/drawing/2014/main" id="{ABBC067B-14C6-45A0-A971-0F5723C1A68C}"/>
               </a:ext>
             </a:extLst>
           </p:cNvPr>
@@ -7559,7 +7559,7 @@
           <p:cNvPr id="7" name="object-7">
             <a:extLst>
               <a:ext uri="{FF2B5EF4-FFF2-40B4-BE49-F238E27FC236}">
-                <a16:creationId xmlns:a16="http://schemas.microsoft.com/office/drawing/2014/main" id="{53CFF351-F6E2-4AE6-AE32-5A31871B167B}"/>
+                <a16:creationId xmlns:a16="http://schemas.microsoft.com/office/drawing/2014/main" id="{104CD231-727B-477B-BE13-297251562A2A}"/>
               </a:ext>
             </a:extLst>
           </p:cNvPr>
@@ -7591,7 +7591,7 @@
           <p:cNvPr id="8" name="object-8">
             <a:extLst>
               <a:ext uri="{FF2B5EF4-FFF2-40B4-BE49-F238E27FC236}">
-                <a16:creationId xmlns:a16="http://schemas.microsoft.com/office/drawing/2014/main" id="{E569C473-3DE6-4D36-BB0D-9F150808EB85}"/>
+                <a16:creationId xmlns:a16="http://schemas.microsoft.com/office/drawing/2014/main" id="{88F33C3F-E7C1-471A-BF2F-2824AEAF0577}"/>
               </a:ext>
             </a:extLst>
           </p:cNvPr>
@@ -7621,7 +7621,7 @@
           <p:cNvPr id="9" name="object-9">
             <a:extLst>
               <a:ext uri="{FF2B5EF4-FFF2-40B4-BE49-F238E27FC236}">
-                <a16:creationId xmlns:a16="http://schemas.microsoft.com/office/drawing/2014/main" id="{ABE7563F-4FAA-4367-8723-0D3C80D67DA7}"/>
+                <a16:creationId xmlns:a16="http://schemas.microsoft.com/office/drawing/2014/main" id="{DD1568CE-981B-4DA1-853D-523DCCD6DB26}"/>
               </a:ext>
             </a:extLst>
           </p:cNvPr>
@@ -7678,7 +7678,7 @@
           <p:cNvPr id="10" name="object-10">
             <a:extLst>
               <a:ext uri="{FF2B5EF4-FFF2-40B4-BE49-F238E27FC236}">
-                <a16:creationId xmlns:a16="http://schemas.microsoft.com/office/drawing/2014/main" id="{A5043327-59BF-48D5-B56C-93B01E9B9898}"/>
+                <a16:creationId xmlns:a16="http://schemas.microsoft.com/office/drawing/2014/main" id="{28E53DB8-48EF-49DE-9466-EA8F9F669001}"/>
               </a:ext>
             </a:extLst>
           </p:cNvPr>
@@ -7735,7 +7735,7 @@
           <p:cNvPr id="11" name="object-11">
             <a:extLst>
               <a:ext uri="{FF2B5EF4-FFF2-40B4-BE49-F238E27FC236}">
-                <a16:creationId xmlns:a16="http://schemas.microsoft.com/office/drawing/2014/main" id="{DD6188D7-8444-419B-B621-1339BA6AE397}"/>
+                <a16:creationId xmlns:a16="http://schemas.microsoft.com/office/drawing/2014/main" id="{DFD5F5CB-692C-482F-913B-5E624BF0174F}"/>
               </a:ext>
             </a:extLst>
           </p:cNvPr>
@@ -7792,7 +7792,7 @@
           <p:cNvPr id="12" name="object-12">
             <a:extLst>
               <a:ext uri="{FF2B5EF4-FFF2-40B4-BE49-F238E27FC236}">
-                <a16:creationId xmlns:a16="http://schemas.microsoft.com/office/drawing/2014/main" id="{2D1159F8-9875-4D21-B707-28DA0A6F3184}"/>
+                <a16:creationId xmlns:a16="http://schemas.microsoft.com/office/drawing/2014/main" id="{32C3E9C7-96A5-4650-98A1-B89E44DDC609}"/>
               </a:ext>
             </a:extLst>
           </p:cNvPr>
@@ -7847,7 +7847,7 @@
     </p:spTree>
     <p:extLst>
       <p:ext uri="{BB962C8B-B14F-4D97-AF65-F5344CB8AC3E}">
-        <p14:creationId xmlns:p14="http://schemas.microsoft.com/office/powerpoint/2010/main" val="1911709040"/>
+        <p14:creationId xmlns:p14="http://schemas.microsoft.com/office/powerpoint/2010/main" val="475288027"/>
       </p:ext>
     </p:extLst>
   </p:cSld>
@@ -8084,7 +8084,7 @@
           <p:cNvPr id="12" name="object-1">
             <a:extLst>
               <a:ext uri="{FF2B5EF4-FFF2-40B4-BE49-F238E27FC236}">
-                <a16:creationId xmlns:a16="http://schemas.microsoft.com/office/drawing/2014/main" id="{DBB85672-FE76-425B-887D-4796264289B0}"/>
+                <a16:creationId xmlns:a16="http://schemas.microsoft.com/office/drawing/2014/main" id="{FC193DEA-AB42-4EFB-BF3F-A685E6DF4C85}"/>
               </a:ext>
             </a:extLst>
           </p:cNvPr>
@@ -8141,7 +8141,7 @@
           <p:cNvPr id="2" name="object-2">
             <a:extLst>
               <a:ext uri="{FF2B5EF4-FFF2-40B4-BE49-F238E27FC236}">
-                <a16:creationId xmlns:a16="http://schemas.microsoft.com/office/drawing/2014/main" id="{F4EAC194-C107-4762-9382-B090DC26E6CD}"/>
+                <a16:creationId xmlns:a16="http://schemas.microsoft.com/office/drawing/2014/main" id="{73C26AA6-3108-4EFC-AFC8-8466946D69CE}"/>
               </a:ext>
             </a:extLst>
           </p:cNvPr>
@@ -8188,7 +8188,7 @@
                 <a:ea typeface="Arial"/>
                 <a:cs typeface="Arial"/>
               </a:rPr>
-              <a:t>Find 15% of 440.</a:t>
+              <a:t>Increase 440 by 15%.</a:t>
             </a:r>
           </a:p>
         </p:txBody>
@@ -8198,7 +8198,7 @@
           <p:cNvPr id="3" name="object-3">
             <a:extLst>
               <a:ext uri="{FF2B5EF4-FFF2-40B4-BE49-F238E27FC236}">
-                <a16:creationId xmlns:a16="http://schemas.microsoft.com/office/drawing/2014/main" id="{B796B30F-F7DD-4D15-B5E0-E0D30340DE63}"/>
+                <a16:creationId xmlns:a16="http://schemas.microsoft.com/office/drawing/2014/main" id="{B919D1BC-BE9D-40B0-862C-1395E68DAE7D}"/>
               </a:ext>
             </a:extLst>
           </p:cNvPr>
@@ -8228,7 +8228,7 @@
           <p:cNvPr id="4" name="object-4">
             <a:extLst>
               <a:ext uri="{FF2B5EF4-FFF2-40B4-BE49-F238E27FC236}">
-                <a16:creationId xmlns:a16="http://schemas.microsoft.com/office/drawing/2014/main" id="{1DF3754D-9D9A-478D-A2F8-190099820F15}"/>
+                <a16:creationId xmlns:a16="http://schemas.microsoft.com/office/drawing/2014/main" id="{E65F10F3-9CD4-4D37-9232-7A94B9D7B27C}"/>
               </a:ext>
             </a:extLst>
           </p:cNvPr>
@@ -8285,7 +8285,7 @@
           <p:cNvPr id="5" name="object-5">
             <a:extLst>
               <a:ext uri="{FF2B5EF4-FFF2-40B4-BE49-F238E27FC236}">
-                <a16:creationId xmlns:a16="http://schemas.microsoft.com/office/drawing/2014/main" id="{066B59A0-9F18-4256-BDB2-016AE077740A}"/>
+                <a16:creationId xmlns:a16="http://schemas.microsoft.com/office/drawing/2014/main" id="{80371D43-7571-42DF-8072-55DDA20C8ACE}"/>
               </a:ext>
             </a:extLst>
           </p:cNvPr>
@@ -8342,7 +8342,7 @@
           <p:cNvPr id="6" name="object-6">
             <a:extLst>
               <a:ext uri="{FF2B5EF4-FFF2-40B4-BE49-F238E27FC236}">
-                <a16:creationId xmlns:a16="http://schemas.microsoft.com/office/drawing/2014/main" id="{0E1A15B2-2637-4765-A803-D96463C9708D}"/>
+                <a16:creationId xmlns:a16="http://schemas.microsoft.com/office/drawing/2014/main" id="{035174D6-A772-41EF-887C-059E8834CC22}"/>
               </a:ext>
             </a:extLst>
           </p:cNvPr>
@@ -8374,7 +8374,7 @@
           <p:cNvPr id="7" name="object-7">
             <a:extLst>
               <a:ext uri="{FF2B5EF4-FFF2-40B4-BE49-F238E27FC236}">
-                <a16:creationId xmlns:a16="http://schemas.microsoft.com/office/drawing/2014/main" id="{7F172F68-FF35-4844-8246-0A199637870B}"/>
+                <a16:creationId xmlns:a16="http://schemas.microsoft.com/office/drawing/2014/main" id="{2A7535A8-5DB5-4F61-AF6A-0134045E5032}"/>
               </a:ext>
             </a:extLst>
           </p:cNvPr>
@@ -8404,7 +8404,7 @@
           <p:cNvPr id="8" name="object-8">
             <a:extLst>
               <a:ext uri="{FF2B5EF4-FFF2-40B4-BE49-F238E27FC236}">
-                <a16:creationId xmlns:a16="http://schemas.microsoft.com/office/drawing/2014/main" id="{0CDAC5D5-82B1-4B01-AAB9-02A8E144DC6D}"/>
+                <a16:creationId xmlns:a16="http://schemas.microsoft.com/office/drawing/2014/main" id="{D8A01B5F-D3A8-47B7-8D96-659E38B25463}"/>
               </a:ext>
             </a:extLst>
           </p:cNvPr>
@@ -8461,7 +8461,7 @@
           <p:cNvPr id="9" name="object-9">
             <a:extLst>
               <a:ext uri="{FF2B5EF4-FFF2-40B4-BE49-F238E27FC236}">
-                <a16:creationId xmlns:a16="http://schemas.microsoft.com/office/drawing/2014/main" id="{A0EA54C0-AF88-4E2C-8351-75C60AFB21CD}"/>
+                <a16:creationId xmlns:a16="http://schemas.microsoft.com/office/drawing/2014/main" id="{DCCB1301-B1F6-4783-9424-E8E2EFAB2B66}"/>
               </a:ext>
             </a:extLst>
           </p:cNvPr>
@@ -8518,7 +8518,7 @@
           <p:cNvPr id="10" name="object-10">
             <a:extLst>
               <a:ext uri="{FF2B5EF4-FFF2-40B4-BE49-F238E27FC236}">
-                <a16:creationId xmlns:a16="http://schemas.microsoft.com/office/drawing/2014/main" id="{80841BD5-6DEA-4CDC-8E6E-5DB3EAC97105}"/>
+                <a16:creationId xmlns:a16="http://schemas.microsoft.com/office/drawing/2014/main" id="{B624669F-6635-4A1F-A8B7-E39611843598}"/>
               </a:ext>
             </a:extLst>
           </p:cNvPr>
@@ -8575,7 +8575,7 @@
           <p:cNvPr id="11" name="object-11">
             <a:extLst>
               <a:ext uri="{FF2B5EF4-FFF2-40B4-BE49-F238E27FC236}">
-                <a16:creationId xmlns:a16="http://schemas.microsoft.com/office/drawing/2014/main" id="{DC555858-1DB9-4FAF-A463-00E3E9075687}"/>
+                <a16:creationId xmlns:a16="http://schemas.microsoft.com/office/drawing/2014/main" id="{9AA437D6-ABC2-4A2F-9595-65A9A8C59365}"/>
               </a:ext>
             </a:extLst>
           </p:cNvPr>
@@ -8622,7 +8622,7 @@
                 <a:ea typeface="Arial"/>
                 <a:cs typeface="Arial"/>
               </a:rPr>
-              <a:t>4.4 × 15 = 66</a:t>
+              <a:t>440 + 66 = 506</a:t>
             </a:r>
           </a:p>
         </p:txBody>
@@ -8630,7 +8630,7 @@
     </p:spTree>
     <p:extLst>
       <p:ext uri="{BB962C8B-B14F-4D97-AF65-F5344CB8AC3E}">
-        <p14:creationId xmlns:p14="http://schemas.microsoft.com/office/powerpoint/2010/main" val="1577796831"/>
+        <p14:creationId xmlns:p14="http://schemas.microsoft.com/office/powerpoint/2010/main" val="1503324920"/>
       </p:ext>
     </p:extLst>
   </p:cSld>
@@ -8867,7 +8867,7 @@
           <p:cNvPr id="12" name="object-1">
             <a:extLst>
               <a:ext uri="{FF2B5EF4-FFF2-40B4-BE49-F238E27FC236}">
-                <a16:creationId xmlns:a16="http://schemas.microsoft.com/office/drawing/2014/main" id="{BEFF2B09-D03F-40E5-8822-7EAC196C2E32}"/>
+                <a16:creationId xmlns:a16="http://schemas.microsoft.com/office/drawing/2014/main" id="{78FE2838-5E5E-42DA-B911-456A32D21573}"/>
               </a:ext>
             </a:extLst>
           </p:cNvPr>
@@ -8924,7 +8924,7 @@
           <p:cNvPr id="2" name="object-2">
             <a:extLst>
               <a:ext uri="{FF2B5EF4-FFF2-40B4-BE49-F238E27FC236}">
-                <a16:creationId xmlns:a16="http://schemas.microsoft.com/office/drawing/2014/main" id="{A1107D1C-1164-4D12-B796-4B422B87EB80}"/>
+                <a16:creationId xmlns:a16="http://schemas.microsoft.com/office/drawing/2014/main" id="{BC238E35-2510-4ABD-BD89-54BF7407D04E}"/>
               </a:ext>
             </a:extLst>
           </p:cNvPr>
@@ -8981,7 +8981,7 @@
           <p:cNvPr id="3" name="object-3">
             <a:extLst>
               <a:ext uri="{FF2B5EF4-FFF2-40B4-BE49-F238E27FC236}">
-                <a16:creationId xmlns:a16="http://schemas.microsoft.com/office/drawing/2014/main" id="{D1937255-3C1F-4483-8B63-1FEA64FDE7D5}"/>
+                <a16:creationId xmlns:a16="http://schemas.microsoft.com/office/drawing/2014/main" id="{2B35469C-0814-4385-92FE-59F7AAA40B23}"/>
               </a:ext>
             </a:extLst>
           </p:cNvPr>
@@ -9011,7 +9011,7 @@
           <p:cNvPr id="4" name="object-4">
             <a:extLst>
               <a:ext uri="{FF2B5EF4-FFF2-40B4-BE49-F238E27FC236}">
-                <a16:creationId xmlns:a16="http://schemas.microsoft.com/office/drawing/2014/main" id="{3AF2CFE9-005B-4C83-8341-D5CB8220C69F}"/>
+                <a16:creationId xmlns:a16="http://schemas.microsoft.com/office/drawing/2014/main" id="{D18B85C7-96CD-4EC6-B5F5-310ABFC9E018}"/>
               </a:ext>
             </a:extLst>
           </p:cNvPr>
@@ -9068,7 +9068,7 @@
           <p:cNvPr id="5" name="object-5">
             <a:extLst>
               <a:ext uri="{FF2B5EF4-FFF2-40B4-BE49-F238E27FC236}">
-                <a16:creationId xmlns:a16="http://schemas.microsoft.com/office/drawing/2014/main" id="{E81747E5-414D-45F0-8F4E-97A01213B8BE}"/>
+                <a16:creationId xmlns:a16="http://schemas.microsoft.com/office/drawing/2014/main" id="{2FCCC1AC-A46F-4EFB-8109-937A4E6CFDF3}"/>
               </a:ext>
             </a:extLst>
           </p:cNvPr>
@@ -9125,7 +9125,7 @@
           <p:cNvPr id="6" name="object-6">
             <a:extLst>
               <a:ext uri="{FF2B5EF4-FFF2-40B4-BE49-F238E27FC236}">
-                <a16:creationId xmlns:a16="http://schemas.microsoft.com/office/drawing/2014/main" id="{71892637-F355-4309-8478-7F9775A7888E}"/>
+                <a16:creationId xmlns:a16="http://schemas.microsoft.com/office/drawing/2014/main" id="{EE39BA06-C169-416A-A41F-CAB4801CE8D7}"/>
               </a:ext>
             </a:extLst>
           </p:cNvPr>
@@ -9157,7 +9157,7 @@
           <p:cNvPr id="7" name="object-7">
             <a:extLst>
               <a:ext uri="{FF2B5EF4-FFF2-40B4-BE49-F238E27FC236}">
-                <a16:creationId xmlns:a16="http://schemas.microsoft.com/office/drawing/2014/main" id="{9042FCB0-F057-45A2-BFF0-95AD569B5A90}"/>
+                <a16:creationId xmlns:a16="http://schemas.microsoft.com/office/drawing/2014/main" id="{773D5670-D9B7-4C6B-A375-DA1975EC3A6A}"/>
               </a:ext>
             </a:extLst>
           </p:cNvPr>
@@ -9187,7 +9187,7 @@
           <p:cNvPr id="8" name="object-8">
             <a:extLst>
               <a:ext uri="{FF2B5EF4-FFF2-40B4-BE49-F238E27FC236}">
-                <a16:creationId xmlns:a16="http://schemas.microsoft.com/office/drawing/2014/main" id="{FFBB3376-ECA1-4326-A048-EDFE22511017}"/>
+                <a16:creationId xmlns:a16="http://schemas.microsoft.com/office/drawing/2014/main" id="{1F615C49-9994-4AAE-A762-FFD716C81B20}"/>
               </a:ext>
             </a:extLst>
           </p:cNvPr>
@@ -9244,7 +9244,7 @@
           <p:cNvPr id="9" name="object-9">
             <a:extLst>
               <a:ext uri="{FF2B5EF4-FFF2-40B4-BE49-F238E27FC236}">
-                <a16:creationId xmlns:a16="http://schemas.microsoft.com/office/drawing/2014/main" id="{25EE7C77-8082-4576-9A70-29A119E6BE90}"/>
+                <a16:creationId xmlns:a16="http://schemas.microsoft.com/office/drawing/2014/main" id="{75329A86-69A9-4945-96E7-CFE17230F913}"/>
               </a:ext>
             </a:extLst>
           </p:cNvPr>
@@ -9301,7 +9301,7 @@
           <p:cNvPr id="10" name="object-10">
             <a:extLst>
               <a:ext uri="{FF2B5EF4-FFF2-40B4-BE49-F238E27FC236}">
-                <a16:creationId xmlns:a16="http://schemas.microsoft.com/office/drawing/2014/main" id="{961CDB72-080B-413C-BD51-A175387C0A94}"/>
+                <a16:creationId xmlns:a16="http://schemas.microsoft.com/office/drawing/2014/main" id="{6299D257-735B-44E3-A1DB-19BBD032EB1B}"/>
               </a:ext>
             </a:extLst>
           </p:cNvPr>
@@ -9358,7 +9358,7 @@
           <p:cNvPr id="11" name="object-11">
             <a:extLst>
               <a:ext uri="{FF2B5EF4-FFF2-40B4-BE49-F238E27FC236}">
-                <a16:creationId xmlns:a16="http://schemas.microsoft.com/office/drawing/2014/main" id="{20C3BB3F-FCA7-4625-8FA3-BE8DA80F05F5}"/>
+                <a16:creationId xmlns:a16="http://schemas.microsoft.com/office/drawing/2014/main" id="{35C59A1B-9912-4546-8D0E-7FE9F3340969}"/>
               </a:ext>
             </a:extLst>
           </p:cNvPr>
@@ -9413,7 +9413,7 @@
     </p:spTree>
     <p:extLst>
       <p:ext uri="{BB962C8B-B14F-4D97-AF65-F5344CB8AC3E}">
-        <p14:creationId xmlns:p14="http://schemas.microsoft.com/office/powerpoint/2010/main" val="157639757"/>
+        <p14:creationId xmlns:p14="http://schemas.microsoft.com/office/powerpoint/2010/main" val="851274990"/>
       </p:ext>
     </p:extLst>
   </p:cSld>
@@ -9650,7 +9650,7 @@
           <p:cNvPr id="13" name="object-1">
             <a:extLst>
               <a:ext uri="{FF2B5EF4-FFF2-40B4-BE49-F238E27FC236}">
-                <a16:creationId xmlns:a16="http://schemas.microsoft.com/office/drawing/2014/main" id="{F7EB7BE1-7E2E-4A00-BA6E-B943D4F5A336}"/>
+                <a16:creationId xmlns:a16="http://schemas.microsoft.com/office/drawing/2014/main" id="{8E283C6A-2B5F-4C73-8447-0A9F75514F36}"/>
               </a:ext>
             </a:extLst>
           </p:cNvPr>
@@ -9707,7 +9707,7 @@
           <p:cNvPr id="2" name="object-2">
             <a:extLst>
               <a:ext uri="{FF2B5EF4-FFF2-40B4-BE49-F238E27FC236}">
-                <a16:creationId xmlns:a16="http://schemas.microsoft.com/office/drawing/2014/main" id="{0536EC77-ED87-42C1-8740-42DDBE0A3609}"/>
+                <a16:creationId xmlns:a16="http://schemas.microsoft.com/office/drawing/2014/main" id="{7B8A42B2-C03F-4568-911B-8A5C41AFF95E}"/>
               </a:ext>
             </a:extLst>
           </p:cNvPr>
@@ -9764,7 +9764,7 @@
           <p:cNvPr id="3" name="object-3">
             <a:extLst>
               <a:ext uri="{FF2B5EF4-FFF2-40B4-BE49-F238E27FC236}">
-                <a16:creationId xmlns:a16="http://schemas.microsoft.com/office/drawing/2014/main" id="{F7787F1A-3F18-4816-B172-758C3D37D4C3}"/>
+                <a16:creationId xmlns:a16="http://schemas.microsoft.com/office/drawing/2014/main" id="{AD2571BD-0CFE-47EA-99A0-E7C8A2F5EE50}"/>
               </a:ext>
             </a:extLst>
           </p:cNvPr>
@@ -9811,7 +9811,7 @@
                 <a:ea typeface="Arial"/>
                 <a:cs typeface="Arial"/>
               </a:rPr>
-              <a:t>Find 15% of 540.</a:t>
+              <a:t>Increase 540 by 15%.</a:t>
             </a:r>
           </a:p>
         </p:txBody>
@@ -9821,7 +9821,7 @@
           <p:cNvPr id="4" name="object-4">
             <a:extLst>
               <a:ext uri="{FF2B5EF4-FFF2-40B4-BE49-F238E27FC236}">
-                <a16:creationId xmlns:a16="http://schemas.microsoft.com/office/drawing/2014/main" id="{FFDA1138-58F0-465F-B0A2-C4BACA0AB90F}"/>
+                <a16:creationId xmlns:a16="http://schemas.microsoft.com/office/drawing/2014/main" id="{B4F242B2-2087-435C-B911-B84D3D52B096}"/>
               </a:ext>
             </a:extLst>
           </p:cNvPr>
@@ -9851,7 +9851,7 @@
           <p:cNvPr id="5" name="object-5">
             <a:extLst>
               <a:ext uri="{FF2B5EF4-FFF2-40B4-BE49-F238E27FC236}">
-                <a16:creationId xmlns:a16="http://schemas.microsoft.com/office/drawing/2014/main" id="{8F1FC112-1A20-4ACE-B37E-D55998981827}"/>
+                <a16:creationId xmlns:a16="http://schemas.microsoft.com/office/drawing/2014/main" id="{D2CA1C60-FCE5-40D5-84FC-862597EDF668}"/>
               </a:ext>
             </a:extLst>
           </p:cNvPr>
@@ -9908,7 +9908,7 @@
           <p:cNvPr id="6" name="object-6">
             <a:extLst>
               <a:ext uri="{FF2B5EF4-FFF2-40B4-BE49-F238E27FC236}">
-                <a16:creationId xmlns:a16="http://schemas.microsoft.com/office/drawing/2014/main" id="{3E8947F9-891B-44E0-9EEC-75002438D2CE}"/>
+                <a16:creationId xmlns:a16="http://schemas.microsoft.com/office/drawing/2014/main" id="{169AF306-1716-4953-B924-26B297C4BDDD}"/>
               </a:ext>
             </a:extLst>
           </p:cNvPr>
@@ -9965,7 +9965,7 @@
           <p:cNvPr id="7" name="object-7">
             <a:extLst>
               <a:ext uri="{FF2B5EF4-FFF2-40B4-BE49-F238E27FC236}">
-                <a16:creationId xmlns:a16="http://schemas.microsoft.com/office/drawing/2014/main" id="{A7EDE3C9-2492-4DFB-93DC-E3102E1ADBA2}"/>
+                <a16:creationId xmlns:a16="http://schemas.microsoft.com/office/drawing/2014/main" id="{D02FD49F-F224-4886-8525-659D8446B810}"/>
               </a:ext>
             </a:extLst>
           </p:cNvPr>
@@ -9997,7 +9997,7 @@
           <p:cNvPr id="8" name="object-8">
             <a:extLst>
               <a:ext uri="{FF2B5EF4-FFF2-40B4-BE49-F238E27FC236}">
-                <a16:creationId xmlns:a16="http://schemas.microsoft.com/office/drawing/2014/main" id="{E18B48FE-1790-4A13-BDAD-E8326466EED6}"/>
+                <a16:creationId xmlns:a16="http://schemas.microsoft.com/office/drawing/2014/main" id="{6543E8C6-6ED0-4E4A-AFB2-781172AE479F}"/>
               </a:ext>
             </a:extLst>
           </p:cNvPr>
@@ -10027,7 +10027,7 @@
           <p:cNvPr id="9" name="object-9">
             <a:extLst>
               <a:ext uri="{FF2B5EF4-FFF2-40B4-BE49-F238E27FC236}">
-                <a16:creationId xmlns:a16="http://schemas.microsoft.com/office/drawing/2014/main" id="{F9547ECE-D125-4D68-9B3C-28D96A5792E7}"/>
+                <a16:creationId xmlns:a16="http://schemas.microsoft.com/office/drawing/2014/main" id="{09B0C9F1-20F1-4B9B-9C51-7296973BA33B}"/>
               </a:ext>
             </a:extLst>
           </p:cNvPr>
@@ -10084,7 +10084,7 @@
           <p:cNvPr id="10" name="object-10">
             <a:extLst>
               <a:ext uri="{FF2B5EF4-FFF2-40B4-BE49-F238E27FC236}">
-                <a16:creationId xmlns:a16="http://schemas.microsoft.com/office/drawing/2014/main" id="{66B95A93-03D4-4804-83D8-97BB2F1B5694}"/>
+                <a16:creationId xmlns:a16="http://schemas.microsoft.com/office/drawing/2014/main" id="{D140CE13-46F2-4AD6-9F19-3EB44FB45FDB}"/>
               </a:ext>
             </a:extLst>
           </p:cNvPr>
@@ -10141,7 +10141,7 @@
           <p:cNvPr id="11" name="object-11">
             <a:extLst>
               <a:ext uri="{FF2B5EF4-FFF2-40B4-BE49-F238E27FC236}">
-                <a16:creationId xmlns:a16="http://schemas.microsoft.com/office/drawing/2014/main" id="{CA85A09D-535E-4D10-B86E-F1837D62D3B4}"/>
+                <a16:creationId xmlns:a16="http://schemas.microsoft.com/office/drawing/2014/main" id="{962DC73A-1A1E-4A30-83B5-4BE35847A27A}"/>
               </a:ext>
             </a:extLst>
           </p:cNvPr>
@@ -10198,7 +10198,7 @@
           <p:cNvPr id="12" name="object-12">
             <a:extLst>
               <a:ext uri="{FF2B5EF4-FFF2-40B4-BE49-F238E27FC236}">
-                <a16:creationId xmlns:a16="http://schemas.microsoft.com/office/drawing/2014/main" id="{269EAF29-86D2-4BE3-A9AC-1F0557A27B2A}"/>
+                <a16:creationId xmlns:a16="http://schemas.microsoft.com/office/drawing/2014/main" id="{13CE282C-A4CC-4FB2-A05A-52150C06B99B}"/>
               </a:ext>
             </a:extLst>
           </p:cNvPr>
@@ -10245,7 +10245,7 @@
                 <a:ea typeface="Arial"/>
                 <a:cs typeface="Arial"/>
               </a:rPr>
-              <a:t>5.4 × 15 = 81</a:t>
+              <a:t>540 + 81 = 621</a:t>
             </a:r>
           </a:p>
         </p:txBody>
@@ -10253,7 +10253,7 @@
     </p:spTree>
     <p:extLst>
       <p:ext uri="{BB962C8B-B14F-4D97-AF65-F5344CB8AC3E}">
-        <p14:creationId xmlns:p14="http://schemas.microsoft.com/office/powerpoint/2010/main" val="167303101"/>
+        <p14:creationId xmlns:p14="http://schemas.microsoft.com/office/powerpoint/2010/main" val="1276448077"/>
       </p:ext>
     </p:extLst>
   </p:cSld>
@@ -10490,7 +10490,7 @@
           <p:cNvPr id="13" name="object-1">
             <a:extLst>
               <a:ext uri="{FF2B5EF4-FFF2-40B4-BE49-F238E27FC236}">
-                <a16:creationId xmlns:a16="http://schemas.microsoft.com/office/drawing/2014/main" id="{47FDC605-CD23-421A-AF69-B1FCC571A723}"/>
+                <a16:creationId xmlns:a16="http://schemas.microsoft.com/office/drawing/2014/main" id="{CCC8F7D9-E125-4CA3-BC08-3C087110C351}"/>
               </a:ext>
             </a:extLst>
           </p:cNvPr>
@@ -10547,7 +10547,7 @@
           <p:cNvPr id="2" name="object-2">
             <a:extLst>
               <a:ext uri="{FF2B5EF4-FFF2-40B4-BE49-F238E27FC236}">
-                <a16:creationId xmlns:a16="http://schemas.microsoft.com/office/drawing/2014/main" id="{5E6F46CD-2368-49FD-94A9-D674820061BD}"/>
+                <a16:creationId xmlns:a16="http://schemas.microsoft.com/office/drawing/2014/main" id="{47EFD3CE-4E5B-4F90-81A7-EECE6B7EF28D}"/>
               </a:ext>
             </a:extLst>
           </p:cNvPr>
@@ -10604,7 +10604,7 @@
           <p:cNvPr id="3" name="object-3">
             <a:extLst>
               <a:ext uri="{FF2B5EF4-FFF2-40B4-BE49-F238E27FC236}">
-                <a16:creationId xmlns:a16="http://schemas.microsoft.com/office/drawing/2014/main" id="{5AC10F61-E655-48F4-A861-EAD1646B3268}"/>
+                <a16:creationId xmlns:a16="http://schemas.microsoft.com/office/drawing/2014/main" id="{1A60E475-BD60-4347-BA64-B96957A6C6F4}"/>
               </a:ext>
             </a:extLst>
           </p:cNvPr>
@@ -10661,7 +10661,7 @@
           <p:cNvPr id="4" name="object-4">
             <a:extLst>
               <a:ext uri="{FF2B5EF4-FFF2-40B4-BE49-F238E27FC236}">
-                <a16:creationId xmlns:a16="http://schemas.microsoft.com/office/drawing/2014/main" id="{E240139A-6CFF-441A-A55F-B48BB3E56098}"/>
+                <a16:creationId xmlns:a16="http://schemas.microsoft.com/office/drawing/2014/main" id="{01C65EC2-8BAF-45C8-BB32-83CF3B7F4B73}"/>
               </a:ext>
             </a:extLst>
           </p:cNvPr>
@@ -10691,7 +10691,7 @@
           <p:cNvPr id="5" name="object-5">
             <a:extLst>
               <a:ext uri="{FF2B5EF4-FFF2-40B4-BE49-F238E27FC236}">
-                <a16:creationId xmlns:a16="http://schemas.microsoft.com/office/drawing/2014/main" id="{62F6021C-A8BF-4552-9B19-C8A9A90DD05F}"/>
+                <a16:creationId xmlns:a16="http://schemas.microsoft.com/office/drawing/2014/main" id="{C710509B-7077-4FEC-8060-58F6C1F718D6}"/>
               </a:ext>
             </a:extLst>
           </p:cNvPr>
@@ -10748,7 +10748,7 @@
           <p:cNvPr id="6" name="object-6">
             <a:extLst>
               <a:ext uri="{FF2B5EF4-FFF2-40B4-BE49-F238E27FC236}">
-                <a16:creationId xmlns:a16="http://schemas.microsoft.com/office/drawing/2014/main" id="{105453A0-A9E3-410F-BCA0-2717D88170D7}"/>
+                <a16:creationId xmlns:a16="http://schemas.microsoft.com/office/drawing/2014/main" id="{09EA2BA5-0ED6-4ECC-B9BF-07AD2F61F3DD}"/>
               </a:ext>
             </a:extLst>
           </p:cNvPr>
@@ -10805,7 +10805,7 @@
           <p:cNvPr id="7" name="object-7">
             <a:extLst>
               <a:ext uri="{FF2B5EF4-FFF2-40B4-BE49-F238E27FC236}">
-                <a16:creationId xmlns:a16="http://schemas.microsoft.com/office/drawing/2014/main" id="{07514BDF-BB88-4B4A-95CD-9154CC13AE96}"/>
+                <a16:creationId xmlns:a16="http://schemas.microsoft.com/office/drawing/2014/main" id="{66F54131-1591-4863-963C-31087729BE9D}"/>
               </a:ext>
             </a:extLst>
           </p:cNvPr>
@@ -10837,7 +10837,7 @@
           <p:cNvPr id="8" name="object-8">
             <a:extLst>
               <a:ext uri="{FF2B5EF4-FFF2-40B4-BE49-F238E27FC236}">
-                <a16:creationId xmlns:a16="http://schemas.microsoft.com/office/drawing/2014/main" id="{F9461F50-D0D5-4AD3-A94C-3EE8D6C6DD68}"/>
+                <a16:creationId xmlns:a16="http://schemas.microsoft.com/office/drawing/2014/main" id="{1259F3D7-1B58-4BD9-948F-FE99BC443665}"/>
               </a:ext>
             </a:extLst>
           </p:cNvPr>
@@ -10867,7 +10867,7 @@
           <p:cNvPr id="9" name="object-9">
             <a:extLst>
               <a:ext uri="{FF2B5EF4-FFF2-40B4-BE49-F238E27FC236}">
-                <a16:creationId xmlns:a16="http://schemas.microsoft.com/office/drawing/2014/main" id="{9D5B31D5-820D-41FE-9652-1D70B5312C4A}"/>
+                <a16:creationId xmlns:a16="http://schemas.microsoft.com/office/drawing/2014/main" id="{96637885-2CF1-4043-9379-58D698B1A98F}"/>
               </a:ext>
             </a:extLst>
           </p:cNvPr>
@@ -10924,7 +10924,7 @@
           <p:cNvPr id="10" name="object-10">
             <a:extLst>
               <a:ext uri="{FF2B5EF4-FFF2-40B4-BE49-F238E27FC236}">
-                <a16:creationId xmlns:a16="http://schemas.microsoft.com/office/drawing/2014/main" id="{70C6A267-7313-4B2C-A43A-45648A26D308}"/>
+                <a16:creationId xmlns:a16="http://schemas.microsoft.com/office/drawing/2014/main" id="{8786E65A-97D6-4F45-B4AB-6ACAADC3D4A1}"/>
               </a:ext>
             </a:extLst>
           </p:cNvPr>
@@ -10981,7 +10981,7 @@
           <p:cNvPr id="11" name="object-11">
             <a:extLst>
               <a:ext uri="{FF2B5EF4-FFF2-40B4-BE49-F238E27FC236}">
-                <a16:creationId xmlns:a16="http://schemas.microsoft.com/office/drawing/2014/main" id="{6467BC1A-3857-4C70-92E5-3C4E19320047}"/>
+                <a16:creationId xmlns:a16="http://schemas.microsoft.com/office/drawing/2014/main" id="{54E173D1-B4DD-45D0-A620-C881405CCCBA}"/>
               </a:ext>
             </a:extLst>
           </p:cNvPr>
@@ -11038,7 +11038,7 @@
           <p:cNvPr id="12" name="object-12">
             <a:extLst>
               <a:ext uri="{FF2B5EF4-FFF2-40B4-BE49-F238E27FC236}">
-                <a16:creationId xmlns:a16="http://schemas.microsoft.com/office/drawing/2014/main" id="{F93057AE-C8A8-4D33-BBCE-509E92B92E03}"/>
+                <a16:creationId xmlns:a16="http://schemas.microsoft.com/office/drawing/2014/main" id="{56D2130C-C785-406C-9E47-ACE6B2DF7434}"/>
               </a:ext>
             </a:extLst>
           </p:cNvPr>
@@ -11093,7 +11093,7 @@
     </p:spTree>
     <p:extLst>
       <p:ext uri="{BB962C8B-B14F-4D97-AF65-F5344CB8AC3E}">
-        <p14:creationId xmlns:p14="http://schemas.microsoft.com/office/powerpoint/2010/main" val="2055229683"/>
+        <p14:creationId xmlns:p14="http://schemas.microsoft.com/office/powerpoint/2010/main" val="1363135838"/>
       </p:ext>
     </p:extLst>
   </p:cSld>

</xml_diff>